<commit_message>
Add ColPali and DeepSeek-OCR-2 figures to PPTX
</commit_message>
<xml_diff>
--- a/poster/poster.pptx
+++ b/poster/poster.pptx
@@ -3726,7 +3726,7 @@
         <p:spPr>
           <a:xfrm>
             <a:off x="792000" y="7920000"/>
-            <a:ext cx="9927000" cy="1080000"/>
+            <a:ext cx="9927000" cy="792000"/>
           </a:xfrm>
           <a:prstGeom prst="rect">
             <a:avLst/>
@@ -3750,15 +3750,39 @@
           </a:p>
         </p:txBody>
       </p:sp>
-      <p:sp>
-        <p:nvSpPr>
-          <p:cNvPr id="18" name="Rectangle 17"/>
+      <p:pic>
+        <p:nvPicPr>
+          <p:cNvPr id="18" name="Picture 17" descr="colpali_architecture.png"/>
+          <p:cNvPicPr>
+            <a:picLocks noChangeAspect="1"/>
+          </p:cNvPicPr>
+          <p:nvPr/>
+        </p:nvPicPr>
+        <p:blipFill>
+          <a:blip r:embed="rId2"/>
+          <a:stretch>
+            <a:fillRect/>
+          </a:stretch>
+        </p:blipFill>
+        <p:spPr>
+          <a:xfrm>
+            <a:off x="792000" y="8748000"/>
+            <a:ext cx="9927000" cy="3655372"/>
+          </a:xfrm>
+          <a:prstGeom prst="rect">
+            <a:avLst/>
+          </a:prstGeom>
+        </p:spPr>
+      </p:pic>
+      <p:sp>
+        <p:nvSpPr>
+          <p:cNvPr id="19" name="Rectangle 18"/>
           <p:cNvSpPr/>
           <p:nvPr/>
         </p:nvSpPr>
         <p:spPr>
           <a:xfrm>
-            <a:off x="792000" y="9072000"/>
+            <a:off x="792000" y="12547372"/>
             <a:ext cx="54000" cy="252000"/>
           </a:xfrm>
           <a:prstGeom prst="rect">
@@ -3793,13 +3817,13 @@
       </p:sp>
       <p:sp>
         <p:nvSpPr>
-          <p:cNvPr id="19" name="TextBox 18"/>
+          <p:cNvPr id="20" name="TextBox 19"/>
           <p:cNvSpPr txBox="1"/>
           <p:nvPr/>
         </p:nvSpPr>
         <p:spPr>
           <a:xfrm>
-            <a:off x="936000" y="9036000"/>
+            <a:off x="936000" y="12511372"/>
             <a:ext cx="9783000" cy="324000"/>
           </a:xfrm>
           <a:prstGeom prst="rect">
@@ -3826,13 +3850,13 @@
       </p:sp>
       <p:sp>
         <p:nvSpPr>
-          <p:cNvPr id="20" name="TextBox 19"/>
+          <p:cNvPr id="21" name="TextBox 20"/>
           <p:cNvSpPr txBox="1"/>
           <p:nvPr/>
         </p:nvSpPr>
         <p:spPr>
           <a:xfrm>
-            <a:off x="792000" y="9396000"/>
+            <a:off x="792000" y="12871372"/>
             <a:ext cx="9927000" cy="720000"/>
           </a:xfrm>
           <a:prstGeom prst="rect">
@@ -3859,13 +3883,13 @@
       </p:sp>
       <p:sp>
         <p:nvSpPr>
-          <p:cNvPr id="21" name="Rectangle 20"/>
+          <p:cNvPr id="22" name="Rectangle 21"/>
           <p:cNvSpPr/>
           <p:nvPr/>
         </p:nvSpPr>
         <p:spPr>
           <a:xfrm>
-            <a:off x="792000" y="10152000"/>
+            <a:off x="792000" y="13627372"/>
             <a:ext cx="9927000" cy="396000"/>
           </a:xfrm>
           <a:prstGeom prst="rect">
@@ -3900,13 +3924,13 @@
       </p:sp>
       <p:sp>
         <p:nvSpPr>
-          <p:cNvPr id="22" name="TextBox 21"/>
+          <p:cNvPr id="23" name="TextBox 22"/>
           <p:cNvSpPr txBox="1"/>
           <p:nvPr/>
         </p:nvSpPr>
         <p:spPr>
           <a:xfrm>
-            <a:off x="900000" y="10188000"/>
+            <a:off x="900000" y="13663372"/>
             <a:ext cx="9783000" cy="396000"/>
           </a:xfrm>
           <a:prstGeom prst="rect">
@@ -3933,13 +3957,13 @@
       </p:sp>
       <p:sp>
         <p:nvSpPr>
-          <p:cNvPr id="23" name="TextBox 22"/>
+          <p:cNvPr id="24" name="TextBox 23"/>
           <p:cNvSpPr txBox="1"/>
           <p:nvPr/>
         </p:nvSpPr>
         <p:spPr>
           <a:xfrm>
-            <a:off x="792000" y="10656000"/>
+            <a:off x="792000" y="14131372"/>
             <a:ext cx="9927000" cy="720000"/>
           </a:xfrm>
           <a:prstGeom prst="rect">
@@ -3966,13 +3990,13 @@
       </p:sp>
       <p:sp>
         <p:nvSpPr>
-          <p:cNvPr id="24" name="Rectangle 23"/>
+          <p:cNvPr id="25" name="Rectangle 24"/>
           <p:cNvSpPr/>
           <p:nvPr/>
         </p:nvSpPr>
         <p:spPr>
           <a:xfrm>
-            <a:off x="792000" y="11448000"/>
+            <a:off x="792000" y="14923372"/>
             <a:ext cx="54000" cy="252000"/>
           </a:xfrm>
           <a:prstGeom prst="rect">
@@ -4007,13 +4031,13 @@
       </p:sp>
       <p:sp>
         <p:nvSpPr>
-          <p:cNvPr id="25" name="TextBox 24"/>
+          <p:cNvPr id="26" name="TextBox 25"/>
           <p:cNvSpPr txBox="1"/>
           <p:nvPr/>
         </p:nvSpPr>
         <p:spPr>
           <a:xfrm>
-            <a:off x="936000" y="11412000"/>
+            <a:off x="936000" y="14887372"/>
             <a:ext cx="9783000" cy="324000"/>
           </a:xfrm>
           <a:prstGeom prst="rect">
@@ -4040,13 +4064,13 @@
       </p:sp>
       <p:sp>
         <p:nvSpPr>
-          <p:cNvPr id="26" name="TextBox 25"/>
+          <p:cNvPr id="27" name="TextBox 26"/>
           <p:cNvSpPr txBox="1"/>
           <p:nvPr/>
         </p:nvSpPr>
         <p:spPr>
           <a:xfrm>
-            <a:off x="864000" y="11772000"/>
+            <a:off x="864000" y="15247372"/>
             <a:ext cx="9855000" cy="342000"/>
           </a:xfrm>
           <a:prstGeom prst="rect">
@@ -4089,13 +4113,13 @@
       </p:sp>
       <p:sp>
         <p:nvSpPr>
-          <p:cNvPr id="27" name="TextBox 26"/>
+          <p:cNvPr id="28" name="TextBox 27"/>
           <p:cNvSpPr txBox="1"/>
           <p:nvPr/>
         </p:nvSpPr>
         <p:spPr>
           <a:xfrm>
-            <a:off x="864000" y="12042000"/>
+            <a:off x="864000" y="15517372"/>
             <a:ext cx="9855000" cy="342000"/>
           </a:xfrm>
           <a:prstGeom prst="rect">
@@ -4138,13 +4162,13 @@
       </p:sp>
       <p:sp>
         <p:nvSpPr>
-          <p:cNvPr id="28" name="TextBox 27"/>
+          <p:cNvPr id="29" name="TextBox 28"/>
           <p:cNvSpPr txBox="1"/>
           <p:nvPr/>
         </p:nvSpPr>
         <p:spPr>
           <a:xfrm>
-            <a:off x="864000" y="12312000"/>
+            <a:off x="864000" y="15787372"/>
             <a:ext cx="9855000" cy="342000"/>
           </a:xfrm>
           <a:prstGeom prst="rect">
@@ -4187,13 +4211,13 @@
       </p:sp>
       <p:sp>
         <p:nvSpPr>
-          <p:cNvPr id="29" name="TextBox 28"/>
+          <p:cNvPr id="30" name="TextBox 29"/>
           <p:cNvSpPr txBox="1"/>
           <p:nvPr/>
         </p:nvSpPr>
         <p:spPr>
           <a:xfrm>
-            <a:off x="864000" y="12582000"/>
+            <a:off x="864000" y="16057372"/>
             <a:ext cx="9855000" cy="342000"/>
           </a:xfrm>
           <a:prstGeom prst="rect">
@@ -4236,7 +4260,7 @@
       </p:sp>
       <p:sp>
         <p:nvSpPr>
-          <p:cNvPr id="30" name="Rectangle 29"/>
+          <p:cNvPr id="31" name="Rectangle 30"/>
           <p:cNvSpPr/>
           <p:nvPr/>
         </p:nvSpPr>
@@ -4277,7 +4301,7 @@
       </p:sp>
       <p:sp>
         <p:nvSpPr>
-          <p:cNvPr id="31" name="TextBox 30"/>
+          <p:cNvPr id="32" name="TextBox 31"/>
           <p:cNvSpPr txBox="1"/>
           <p:nvPr/>
         </p:nvSpPr>
@@ -4310,7 +4334,7 @@
       </p:sp>
       <p:sp>
         <p:nvSpPr>
-          <p:cNvPr id="32" name="Rectangle 31"/>
+          <p:cNvPr id="33" name="Rectangle 32"/>
           <p:cNvSpPr/>
           <p:nvPr/>
         </p:nvSpPr>
@@ -4351,7 +4375,7 @@
       </p:sp>
       <p:sp>
         <p:nvSpPr>
-          <p:cNvPr id="33" name="Rectangle 32"/>
+          <p:cNvPr id="34" name="Rectangle 33"/>
           <p:cNvSpPr/>
           <p:nvPr/>
         </p:nvSpPr>
@@ -4392,7 +4416,7 @@
       </p:sp>
       <p:sp>
         <p:nvSpPr>
-          <p:cNvPr id="34" name="TextBox 33"/>
+          <p:cNvPr id="35" name="TextBox 34"/>
           <p:cNvSpPr txBox="1"/>
           <p:nvPr/>
         </p:nvSpPr>
@@ -4425,7 +4449,7 @@
       </p:sp>
       <p:sp>
         <p:nvSpPr>
-          <p:cNvPr id="35" name="Rectangle 34"/>
+          <p:cNvPr id="36" name="Rectangle 35"/>
           <p:cNvSpPr/>
           <p:nvPr/>
         </p:nvSpPr>
@@ -4466,7 +4490,7 @@
       </p:sp>
       <p:sp>
         <p:nvSpPr>
-          <p:cNvPr id="36" name="TextBox 35"/>
+          <p:cNvPr id="37" name="TextBox 36"/>
           <p:cNvSpPr txBox="1"/>
           <p:nvPr/>
         </p:nvSpPr>
@@ -4499,7 +4523,7 @@
       </p:sp>
       <p:sp>
         <p:nvSpPr>
-          <p:cNvPr id="37" name="TextBox 36"/>
+          <p:cNvPr id="38" name="TextBox 37"/>
           <p:cNvSpPr txBox="1"/>
           <p:nvPr/>
         </p:nvSpPr>
@@ -4548,7 +4572,7 @@
       </p:sp>
       <p:sp>
         <p:nvSpPr>
-          <p:cNvPr id="38" name="TextBox 37"/>
+          <p:cNvPr id="39" name="TextBox 38"/>
           <p:cNvSpPr txBox="1"/>
           <p:nvPr/>
         </p:nvSpPr>
@@ -4597,7 +4621,7 @@
       </p:sp>
       <p:sp>
         <p:nvSpPr>
-          <p:cNvPr id="39" name="TextBox 38"/>
+          <p:cNvPr id="40" name="TextBox 39"/>
           <p:cNvSpPr txBox="1"/>
           <p:nvPr/>
         </p:nvSpPr>
@@ -4646,7 +4670,7 @@
       </p:sp>
       <p:sp>
         <p:nvSpPr>
-          <p:cNvPr id="40" name="Rectangle 39"/>
+          <p:cNvPr id="41" name="Rectangle 40"/>
           <p:cNvSpPr/>
           <p:nvPr/>
         </p:nvSpPr>
@@ -4687,7 +4711,7 @@
       </p:sp>
       <p:sp>
         <p:nvSpPr>
-          <p:cNvPr id="41" name="TextBox 40"/>
+          <p:cNvPr id="42" name="TextBox 41"/>
           <p:cNvSpPr txBox="1"/>
           <p:nvPr/>
         </p:nvSpPr>
@@ -4720,7 +4744,7 @@
       </p:sp>
       <p:sp>
         <p:nvSpPr>
-          <p:cNvPr id="42" name="TextBox 41"/>
+          <p:cNvPr id="43" name="TextBox 42"/>
           <p:cNvSpPr txBox="1"/>
           <p:nvPr/>
         </p:nvSpPr>
@@ -4769,7 +4793,7 @@
       </p:sp>
       <p:sp>
         <p:nvSpPr>
-          <p:cNvPr id="43" name="TextBox 42"/>
+          <p:cNvPr id="44" name="TextBox 43"/>
           <p:cNvSpPr txBox="1"/>
           <p:nvPr/>
         </p:nvSpPr>
@@ -4818,7 +4842,7 @@
       </p:sp>
       <p:sp>
         <p:nvSpPr>
-          <p:cNvPr id="44" name="TextBox 43"/>
+          <p:cNvPr id="45" name="TextBox 44"/>
           <p:cNvSpPr txBox="1"/>
           <p:nvPr/>
         </p:nvSpPr>
@@ -4867,7 +4891,7 @@
       </p:sp>
       <p:sp>
         <p:nvSpPr>
-          <p:cNvPr id="45" name="TextBox 44"/>
+          <p:cNvPr id="46" name="TextBox 45"/>
           <p:cNvSpPr txBox="1"/>
           <p:nvPr/>
         </p:nvSpPr>
@@ -4900,7 +4924,7 @@
       </p:sp>
       <p:sp>
         <p:nvSpPr>
-          <p:cNvPr id="46" name="Rectangle 45"/>
+          <p:cNvPr id="47" name="Rectangle 46"/>
           <p:cNvSpPr/>
           <p:nvPr/>
         </p:nvSpPr>
@@ -4941,7 +4965,7 @@
       </p:sp>
       <p:sp>
         <p:nvSpPr>
-          <p:cNvPr id="47" name="TextBox 46"/>
+          <p:cNvPr id="48" name="TextBox 47"/>
           <p:cNvSpPr txBox="1"/>
           <p:nvPr/>
         </p:nvSpPr>
@@ -4974,14 +4998,14 @@
       </p:sp>
       <p:sp>
         <p:nvSpPr>
-          <p:cNvPr id="48" name="TextBox 47"/>
+          <p:cNvPr id="49" name="TextBox 48"/>
           <p:cNvSpPr txBox="1"/>
           <p:nvPr/>
         </p:nvSpPr>
         <p:spPr>
           <a:xfrm>
             <a:off x="11223000" y="7956000"/>
-            <a:ext cx="9927000" cy="720000"/>
+            <a:ext cx="9927000" cy="576000"/>
           </a:xfrm>
           <a:prstGeom prst="rect">
             <a:avLst/>
@@ -5005,15 +5029,39 @@
           </a:p>
         </p:txBody>
       </p:sp>
-      <p:sp>
-        <p:nvSpPr>
-          <p:cNvPr id="49" name="Rectangle 48"/>
+      <p:pic>
+        <p:nvPicPr>
+          <p:cNvPr id="50" name="Picture 49" descr="deepseek_ocr2_fig3.jpg"/>
+          <p:cNvPicPr>
+            <a:picLocks noChangeAspect="1"/>
+          </p:cNvPicPr>
+          <p:nvPr/>
+        </p:nvPicPr>
+        <p:blipFill>
+          <a:blip r:embed="rId3"/>
+          <a:stretch>
+            <a:fillRect/>
+          </a:stretch>
+        </p:blipFill>
+        <p:spPr>
+          <a:xfrm>
+            <a:off x="11223000" y="8568000"/>
+            <a:ext cx="9927000" cy="3209730"/>
+          </a:xfrm>
+          <a:prstGeom prst="rect">
+            <a:avLst/>
+          </a:prstGeom>
+        </p:spPr>
+      </p:pic>
+      <p:sp>
+        <p:nvSpPr>
+          <p:cNvPr id="51" name="Rectangle 50"/>
           <p:cNvSpPr/>
           <p:nvPr/>
         </p:nvSpPr>
         <p:spPr>
           <a:xfrm>
-            <a:off x="11223000" y="8748000"/>
+            <a:off x="11223000" y="11921730"/>
             <a:ext cx="54000" cy="252000"/>
           </a:xfrm>
           <a:prstGeom prst="rect">
@@ -5048,13 +5096,13 @@
       </p:sp>
       <p:sp>
         <p:nvSpPr>
-          <p:cNvPr id="50" name="TextBox 49"/>
+          <p:cNvPr id="52" name="TextBox 51"/>
           <p:cNvSpPr txBox="1"/>
           <p:nvPr/>
         </p:nvSpPr>
         <p:spPr>
           <a:xfrm>
-            <a:off x="11367000" y="8712000"/>
+            <a:off x="11367000" y="11885730"/>
             <a:ext cx="9783000" cy="324000"/>
           </a:xfrm>
           <a:prstGeom prst="rect">
@@ -5081,13 +5129,13 @@
       </p:sp>
       <p:sp>
         <p:nvSpPr>
-          <p:cNvPr id="51" name="TextBox 50"/>
+          <p:cNvPr id="53" name="TextBox 52"/>
           <p:cNvSpPr txBox="1"/>
           <p:nvPr/>
         </p:nvSpPr>
         <p:spPr>
           <a:xfrm>
-            <a:off x="11295000" y="9072000"/>
+            <a:off x="11295000" y="12245730"/>
             <a:ext cx="9855000" cy="342000"/>
           </a:xfrm>
           <a:prstGeom prst="rect">
@@ -5130,13 +5178,13 @@
       </p:sp>
       <p:sp>
         <p:nvSpPr>
-          <p:cNvPr id="52" name="TextBox 51"/>
+          <p:cNvPr id="54" name="TextBox 53"/>
           <p:cNvSpPr txBox="1"/>
           <p:nvPr/>
         </p:nvSpPr>
         <p:spPr>
           <a:xfrm>
-            <a:off x="11295000" y="9342000"/>
+            <a:off x="11295000" y="12515730"/>
             <a:ext cx="9855000" cy="342000"/>
           </a:xfrm>
           <a:prstGeom prst="rect">
@@ -5179,13 +5227,13 @@
       </p:sp>
       <p:sp>
         <p:nvSpPr>
-          <p:cNvPr id="53" name="TextBox 52"/>
+          <p:cNvPr id="55" name="TextBox 54"/>
           <p:cNvSpPr txBox="1"/>
           <p:nvPr/>
         </p:nvSpPr>
         <p:spPr>
           <a:xfrm>
-            <a:off x="11295000" y="9612000"/>
+            <a:off x="11295000" y="12785730"/>
             <a:ext cx="9855000" cy="342000"/>
           </a:xfrm>
           <a:prstGeom prst="rect">
@@ -5228,13 +5276,13 @@
       </p:sp>
       <p:sp>
         <p:nvSpPr>
-          <p:cNvPr id="54" name="TextBox 53"/>
+          <p:cNvPr id="56" name="TextBox 55"/>
           <p:cNvSpPr txBox="1"/>
           <p:nvPr/>
         </p:nvSpPr>
         <p:spPr>
           <a:xfrm>
-            <a:off x="11295000" y="9882000"/>
+            <a:off x="11295000" y="13055730"/>
             <a:ext cx="9855000" cy="342000"/>
           </a:xfrm>
           <a:prstGeom prst="rect">
@@ -5277,7 +5325,7 @@
       </p:sp>
       <p:sp>
         <p:nvSpPr>
-          <p:cNvPr id="55" name="Rectangle 54"/>
+          <p:cNvPr id="57" name="Rectangle 56"/>
           <p:cNvSpPr/>
           <p:nvPr/>
         </p:nvSpPr>
@@ -5318,7 +5366,7 @@
       </p:sp>
       <p:sp>
         <p:nvSpPr>
-          <p:cNvPr id="56" name="TextBox 55"/>
+          <p:cNvPr id="58" name="TextBox 57"/>
           <p:cNvSpPr txBox="1"/>
           <p:nvPr/>
         </p:nvSpPr>
@@ -5351,7 +5399,7 @@
       </p:sp>
       <p:sp>
         <p:nvSpPr>
-          <p:cNvPr id="57" name="Rectangle 56"/>
+          <p:cNvPr id="59" name="Rectangle 58"/>
           <p:cNvSpPr/>
           <p:nvPr/>
         </p:nvSpPr>
@@ -5392,7 +5440,7 @@
       </p:sp>
       <p:sp>
         <p:nvSpPr>
-          <p:cNvPr id="58" name="TextBox 57"/>
+          <p:cNvPr id="60" name="TextBox 59"/>
           <p:cNvSpPr txBox="1"/>
           <p:nvPr/>
         </p:nvSpPr>
@@ -5425,7 +5473,7 @@
       </p:sp>
       <p:graphicFrame>
         <p:nvGraphicFramePr>
-          <p:cNvPr id="59" name="Table 58"/>
+          <p:cNvPr id="61" name="Table 60"/>
           <p:cNvGraphicFramePr>
             <a:graphicFrameLocks noGrp="1"/>
           </p:cNvGraphicFramePr>
@@ -5845,7 +5893,7 @@
       </p:graphicFrame>
       <p:sp>
         <p:nvSpPr>
-          <p:cNvPr id="60" name="Rectangle 59"/>
+          <p:cNvPr id="62" name="Rectangle 61"/>
           <p:cNvSpPr/>
           <p:nvPr/>
         </p:nvSpPr>
@@ -5886,7 +5934,7 @@
       </p:sp>
       <p:sp>
         <p:nvSpPr>
-          <p:cNvPr id="61" name="TextBox 60"/>
+          <p:cNvPr id="63" name="TextBox 62"/>
           <p:cNvSpPr txBox="1"/>
           <p:nvPr/>
         </p:nvSpPr>
@@ -5919,7 +5967,7 @@
       </p:sp>
       <p:graphicFrame>
         <p:nvGraphicFramePr>
-          <p:cNvPr id="62" name="Table 61"/>
+          <p:cNvPr id="64" name="Table 63"/>
           <p:cNvGraphicFramePr>
             <a:graphicFrameLocks noGrp="1"/>
           </p:cNvGraphicFramePr>
@@ -6583,7 +6631,7 @@
       </p:graphicFrame>
       <p:sp>
         <p:nvSpPr>
-          <p:cNvPr id="63" name="Rectangle 62"/>
+          <p:cNvPr id="65" name="Rectangle 64"/>
           <p:cNvSpPr/>
           <p:nvPr/>
         </p:nvSpPr>
@@ -6624,7 +6672,7 @@
       </p:sp>
       <p:sp>
         <p:nvSpPr>
-          <p:cNvPr id="64" name="TextBox 63"/>
+          <p:cNvPr id="66" name="TextBox 65"/>
           <p:cNvSpPr txBox="1"/>
           <p:nvPr/>
         </p:nvSpPr>
@@ -6657,7 +6705,7 @@
       </p:sp>
       <p:graphicFrame>
         <p:nvGraphicFramePr>
-          <p:cNvPr id="65" name="Table 64"/>
+          <p:cNvPr id="67" name="Table 66"/>
           <p:cNvGraphicFramePr>
             <a:graphicFrameLocks noGrp="1"/>
           </p:cNvGraphicFramePr>
@@ -7406,7 +7454,7 @@
       </p:graphicFrame>
       <p:sp>
         <p:nvSpPr>
-          <p:cNvPr id="66" name="Rectangle 65"/>
+          <p:cNvPr id="68" name="Rectangle 67"/>
           <p:cNvSpPr/>
           <p:nvPr/>
         </p:nvSpPr>
@@ -7447,7 +7495,7 @@
       </p:sp>
       <p:sp>
         <p:nvSpPr>
-          <p:cNvPr id="67" name="TextBox 66"/>
+          <p:cNvPr id="69" name="TextBox 68"/>
           <p:cNvSpPr txBox="1"/>
           <p:nvPr/>
         </p:nvSpPr>
@@ -7480,7 +7528,7 @@
       </p:sp>
       <p:sp>
         <p:nvSpPr>
-          <p:cNvPr id="68" name="Rectangle 67"/>
+          <p:cNvPr id="70" name="Rectangle 69"/>
           <p:cNvSpPr/>
           <p:nvPr/>
         </p:nvSpPr>
@@ -7521,7 +7569,7 @@
       </p:sp>
       <p:sp>
         <p:nvSpPr>
-          <p:cNvPr id="69" name="Rectangle 68"/>
+          <p:cNvPr id="71" name="Rectangle 70"/>
           <p:cNvSpPr/>
           <p:nvPr/>
         </p:nvSpPr>
@@ -7562,7 +7610,7 @@
       </p:sp>
       <p:sp>
         <p:nvSpPr>
-          <p:cNvPr id="70" name="TextBox 69"/>
+          <p:cNvPr id="72" name="TextBox 71"/>
           <p:cNvSpPr txBox="1"/>
           <p:nvPr/>
         </p:nvSpPr>
@@ -7595,7 +7643,7 @@
       </p:sp>
       <p:sp>
         <p:nvSpPr>
-          <p:cNvPr id="71" name="Rectangle 70"/>
+          <p:cNvPr id="73" name="Rectangle 72"/>
           <p:cNvSpPr/>
           <p:nvPr/>
         </p:nvSpPr>
@@ -7636,7 +7684,7 @@
       </p:sp>
       <p:sp>
         <p:nvSpPr>
-          <p:cNvPr id="72" name="TextBox 71"/>
+          <p:cNvPr id="74" name="TextBox 73"/>
           <p:cNvSpPr txBox="1"/>
           <p:nvPr/>
         </p:nvSpPr>
@@ -7669,7 +7717,7 @@
       </p:sp>
       <p:sp>
         <p:nvSpPr>
-          <p:cNvPr id="73" name="TextBox 72"/>
+          <p:cNvPr id="75" name="TextBox 74"/>
           <p:cNvSpPr txBox="1"/>
           <p:nvPr/>
         </p:nvSpPr>
@@ -7718,7 +7766,7 @@
       </p:sp>
       <p:sp>
         <p:nvSpPr>
-          <p:cNvPr id="74" name="TextBox 73"/>
+          <p:cNvPr id="76" name="TextBox 75"/>
           <p:cNvSpPr txBox="1"/>
           <p:nvPr/>
         </p:nvSpPr>
@@ -7767,7 +7815,7 @@
       </p:sp>
       <p:sp>
         <p:nvSpPr>
-          <p:cNvPr id="75" name="Rectangle 74"/>
+          <p:cNvPr id="77" name="Rectangle 76"/>
           <p:cNvSpPr/>
           <p:nvPr/>
         </p:nvSpPr>
@@ -7808,7 +7856,7 @@
       </p:sp>
       <p:sp>
         <p:nvSpPr>
-          <p:cNvPr id="76" name="TextBox 75"/>
+          <p:cNvPr id="78" name="TextBox 77"/>
           <p:cNvSpPr txBox="1"/>
           <p:nvPr/>
         </p:nvSpPr>
@@ -7841,7 +7889,7 @@
       </p:sp>
       <p:sp>
         <p:nvSpPr>
-          <p:cNvPr id="77" name="TextBox 76"/>
+          <p:cNvPr id="79" name="TextBox 78"/>
           <p:cNvSpPr txBox="1"/>
           <p:nvPr/>
         </p:nvSpPr>
@@ -7890,7 +7938,7 @@
       </p:sp>
       <p:sp>
         <p:nvSpPr>
-          <p:cNvPr id="78" name="TextBox 77"/>
+          <p:cNvPr id="80" name="TextBox 79"/>
           <p:cNvSpPr txBox="1"/>
           <p:nvPr/>
         </p:nvSpPr>
@@ -7939,7 +7987,7 @@
       </p:sp>
       <p:sp>
         <p:nvSpPr>
-          <p:cNvPr id="79" name="Rectangle 78"/>
+          <p:cNvPr id="81" name="Rectangle 80"/>
           <p:cNvSpPr/>
           <p:nvPr/>
         </p:nvSpPr>
@@ -7980,7 +8028,7 @@
       </p:sp>
       <p:sp>
         <p:nvSpPr>
-          <p:cNvPr id="80" name="TextBox 79"/>
+          <p:cNvPr id="82" name="TextBox 81"/>
           <p:cNvSpPr txBox="1"/>
           <p:nvPr/>
         </p:nvSpPr>
@@ -8013,7 +8061,7 @@
       </p:sp>
       <p:sp>
         <p:nvSpPr>
-          <p:cNvPr id="81" name="TextBox 80"/>
+          <p:cNvPr id="83" name="TextBox 82"/>
           <p:cNvSpPr txBox="1"/>
           <p:nvPr/>
         </p:nvSpPr>
@@ -8062,7 +8110,7 @@
       </p:sp>
       <p:sp>
         <p:nvSpPr>
-          <p:cNvPr id="82" name="TextBox 81"/>
+          <p:cNvPr id="84" name="TextBox 83"/>
           <p:cNvSpPr txBox="1"/>
           <p:nvPr/>
         </p:nvSpPr>
@@ -8111,7 +8159,7 @@
       </p:sp>
       <p:sp>
         <p:nvSpPr>
-          <p:cNvPr id="83" name="TextBox 82"/>
+          <p:cNvPr id="85" name="TextBox 84"/>
           <p:cNvSpPr txBox="1"/>
           <p:nvPr/>
         </p:nvSpPr>
@@ -8160,7 +8208,7 @@
       </p:sp>
       <p:sp>
         <p:nvSpPr>
-          <p:cNvPr id="84" name="TextBox 83"/>
+          <p:cNvPr id="86" name="TextBox 85"/>
           <p:cNvSpPr txBox="1"/>
           <p:nvPr/>
         </p:nvSpPr>
@@ -8209,7 +8257,7 @@
       </p:sp>
       <p:sp>
         <p:nvSpPr>
-          <p:cNvPr id="85" name="Rectangle 84"/>
+          <p:cNvPr id="87" name="Rectangle 86"/>
           <p:cNvSpPr/>
           <p:nvPr/>
         </p:nvSpPr>
@@ -8250,7 +8298,7 @@
       </p:sp>
       <p:sp>
         <p:nvSpPr>
-          <p:cNvPr id="86" name="TextBox 85"/>
+          <p:cNvPr id="88" name="TextBox 87"/>
           <p:cNvSpPr txBox="1"/>
           <p:nvPr/>
         </p:nvSpPr>
@@ -8283,7 +8331,7 @@
       </p:sp>
       <p:sp>
         <p:nvSpPr>
-          <p:cNvPr id="87" name="Rectangle 86"/>
+          <p:cNvPr id="89" name="Rectangle 88"/>
           <p:cNvSpPr/>
           <p:nvPr/>
         </p:nvSpPr>
@@ -8324,7 +8372,7 @@
       </p:sp>
       <p:sp>
         <p:nvSpPr>
-          <p:cNvPr id="88" name="TextBox 87"/>
+          <p:cNvPr id="90" name="TextBox 89"/>
           <p:cNvSpPr txBox="1"/>
           <p:nvPr/>
         </p:nvSpPr>
@@ -8357,7 +8405,7 @@
       </p:sp>
       <p:sp>
         <p:nvSpPr>
-          <p:cNvPr id="89" name="TextBox 88"/>
+          <p:cNvPr id="91" name="TextBox 90"/>
           <p:cNvSpPr txBox="1"/>
           <p:nvPr/>
         </p:nvSpPr>
@@ -8406,7 +8454,7 @@
       </p:sp>
       <p:sp>
         <p:nvSpPr>
-          <p:cNvPr id="90" name="TextBox 89"/>
+          <p:cNvPr id="92" name="TextBox 91"/>
           <p:cNvSpPr txBox="1"/>
           <p:nvPr/>
         </p:nvSpPr>
@@ -8455,7 +8503,7 @@
       </p:sp>
       <p:sp>
         <p:nvSpPr>
-          <p:cNvPr id="91" name="Rectangle 90"/>
+          <p:cNvPr id="93" name="Rectangle 92"/>
           <p:cNvSpPr/>
           <p:nvPr/>
         </p:nvSpPr>
@@ -8496,7 +8544,7 @@
       </p:sp>
       <p:sp>
         <p:nvSpPr>
-          <p:cNvPr id="92" name="TextBox 91"/>
+          <p:cNvPr id="94" name="TextBox 93"/>
           <p:cNvSpPr txBox="1"/>
           <p:nvPr/>
         </p:nvSpPr>
@@ -8529,7 +8577,7 @@
       </p:sp>
       <p:sp>
         <p:nvSpPr>
-          <p:cNvPr id="93" name="TextBox 92"/>
+          <p:cNvPr id="95" name="TextBox 94"/>
           <p:cNvSpPr txBox="1"/>
           <p:nvPr/>
         </p:nvSpPr>
@@ -8578,7 +8626,7 @@
       </p:sp>
       <p:sp>
         <p:nvSpPr>
-          <p:cNvPr id="94" name="TextBox 93"/>
+          <p:cNvPr id="96" name="TextBox 95"/>
           <p:cNvSpPr txBox="1"/>
           <p:nvPr/>
         </p:nvSpPr>
@@ -8627,7 +8675,7 @@
       </p:sp>
       <p:sp>
         <p:nvSpPr>
-          <p:cNvPr id="95" name="TextBox 94"/>
+          <p:cNvPr id="97" name="TextBox 96"/>
           <p:cNvSpPr txBox="1"/>
           <p:nvPr/>
         </p:nvSpPr>
@@ -8676,7 +8724,7 @@
       </p:sp>
       <p:sp>
         <p:nvSpPr>
-          <p:cNvPr id="96" name="TextBox 95"/>
+          <p:cNvPr id="98" name="TextBox 97"/>
           <p:cNvSpPr txBox="1"/>
           <p:nvPr/>
         </p:nvSpPr>
@@ -8725,7 +8773,7 @@
       </p:sp>
       <p:sp>
         <p:nvSpPr>
-          <p:cNvPr id="97" name="Rectangle 96"/>
+          <p:cNvPr id="99" name="Rectangle 98"/>
           <p:cNvSpPr/>
           <p:nvPr/>
         </p:nvSpPr>
@@ -8766,7 +8814,7 @@
       </p:sp>
       <p:sp>
         <p:nvSpPr>
-          <p:cNvPr id="98" name="TextBox 97"/>
+          <p:cNvPr id="100" name="TextBox 99"/>
           <p:cNvSpPr txBox="1"/>
           <p:nvPr/>
         </p:nvSpPr>
@@ -8799,7 +8847,7 @@
       </p:sp>
       <p:sp>
         <p:nvSpPr>
-          <p:cNvPr id="99" name="TextBox 98"/>
+          <p:cNvPr id="101" name="TextBox 100"/>
           <p:cNvSpPr txBox="1"/>
           <p:nvPr/>
         </p:nvSpPr>
@@ -8848,7 +8896,7 @@
       </p:sp>
       <p:sp>
         <p:nvSpPr>
-          <p:cNvPr id="100" name="TextBox 99"/>
+          <p:cNvPr id="102" name="TextBox 101"/>
           <p:cNvSpPr txBox="1"/>
           <p:nvPr/>
         </p:nvSpPr>
@@ -8897,7 +8945,7 @@
       </p:sp>
       <p:sp>
         <p:nvSpPr>
-          <p:cNvPr id="101" name="TextBox 100"/>
+          <p:cNvPr id="103" name="TextBox 102"/>
           <p:cNvSpPr txBox="1"/>
           <p:nvPr/>
         </p:nvSpPr>
@@ -8946,7 +8994,7 @@
       </p:sp>
       <p:sp>
         <p:nvSpPr>
-          <p:cNvPr id="102" name="TextBox 101"/>
+          <p:cNvPr id="104" name="TextBox 103"/>
           <p:cNvSpPr txBox="1"/>
           <p:nvPr/>
         </p:nvSpPr>
@@ -8995,7 +9043,7 @@
       </p:sp>
       <p:sp>
         <p:nvSpPr>
-          <p:cNvPr id="103" name="Rectangle 102"/>
+          <p:cNvPr id="105" name="Rectangle 104"/>
           <p:cNvSpPr/>
           <p:nvPr/>
         </p:nvSpPr>
@@ -9036,7 +9084,7 @@
       </p:sp>
       <p:sp>
         <p:nvSpPr>
-          <p:cNvPr id="104" name="TextBox 103"/>
+          <p:cNvPr id="106" name="TextBox 105"/>
           <p:cNvSpPr txBox="1"/>
           <p:nvPr/>
         </p:nvSpPr>

</xml_diff>

<commit_message>
Swap title/subtitle order, center header, make main title bigger
</commit_message>
<xml_diff>
--- a/poster/poster.pptx
+++ b/poster/poster.pptx
@@ -3118,16 +3118,28 @@
           </a:bodyPr>
           <a:lstStyle/>
           <a:p>
-            <a:r>
-              <a:rPr sz="3400" b="1" i="0">
+            <a:pPr algn="ctr"/>
+            <a:r>
+              <a:rPr sz="4200" b="1" i="0">
                 <a:solidFill>
                   <a:srgbClr val="1B3A6B"/>
                 </a:solidFill>
               </a:rPr>
+              <a:t>Does adding image retrieval help a strong text-based RAG?</a:t>
+            </a:r>
+          </a:p>
+          <a:p>
+            <a:pPr algn="ctr"/>
+            <a:r>
+              <a:rPr sz="2200" b="0" i="0">
+                <a:solidFill>
+                  <a:srgbClr val="666666"/>
+                </a:solidFill>
+              </a:rPr>
               <a:t>Reproducing </a:t>
             </a:r>
             <a:r>
-              <a:rPr sz="3400" b="1" i="0">
+              <a:rPr sz="2200" b="0" i="0">
                 <a:solidFill>
                   <a:srgbClr val="C97B2C"/>
                 </a:solidFill>
@@ -3135,25 +3147,16 @@
               <a:t>ViDoRe v3</a:t>
             </a:r>
             <a:r>
-              <a:rPr sz="3400" b="1" i="0">
-                <a:solidFill>
-                  <a:srgbClr val="1B3A6B"/>
+              <a:rPr sz="2200" b="0" i="0">
+                <a:solidFill>
+                  <a:srgbClr val="666666"/>
                 </a:solidFill>
               </a:rPr>
               <a:t> with open-weights models</a:t>
             </a:r>
           </a:p>
           <a:p>
-            <a:r>
-              <a:rPr sz="2000" b="0" i="0">
-                <a:solidFill>
-                  <a:srgbClr val="C97B2C"/>
-                </a:solidFill>
-              </a:rPr>
-              <a:t>Does adding image retrieval help a strong text-based RAG?</a:t>
-            </a:r>
-          </a:p>
-          <a:p>
+            <a:pPr algn="ctr"/>
             <a:r>
               <a:rPr sz="1300" b="0" i="0">
                 <a:solidFill>
@@ -3164,6 +3167,7 @@
             </a:r>
           </a:p>
           <a:p>
+            <a:pPr algn="ctr"/>
             <a:r>
               <a:rPr sz="1100" b="0" i="1">
                 <a:solidFill>

</xml_diff>

<commit_message>
Recreate pipeline SVG as editable PowerPoint shapes and connectors
</commit_message>
<xml_diff>
--- a/poster/poster.pptx
+++ b/poster/poster.pptx
@@ -4503,169 +4503,26 @@
       </p:sp>
       <p:sp>
         <p:nvSpPr>
-          <p:cNvPr id="37" name="TextBox 36"/>
-          <p:cNvSpPr txBox="1"/>
-          <p:nvPr/>
-        </p:nvSpPr>
-        <p:spPr>
-          <a:xfrm>
-            <a:off x="11295000" y="5976000"/>
-            <a:ext cx="9855000" cy="491040"/>
-          </a:xfrm>
-          <a:prstGeom prst="rect">
-            <a:avLst/>
-          </a:prstGeom>
-          <a:noFill/>
-        </p:spPr>
-        <p:txBody>
-          <a:bodyPr wrap="square">
-            <a:spAutoFit/>
-          </a:bodyPr>
-          <a:lstStyle/>
-          <a:p>
-            <a:r>
-              <a:rPr sz="1200" b="0" i="0">
-                <a:solidFill>
-                  <a:srgbClr val="C97B2C"/>
-                </a:solidFill>
-              </a:rPr>
-              <a:t>• </a:t>
-            </a:r>
-            <a:r>
-              <a:rPr sz="1200" b="1" i="0">
-                <a:solidFill>
-                  <a:srgbClr val="1D1D1D"/>
-                </a:solidFill>
-              </a:rPr>
-              <a:t>Text stream: </a:t>
-            </a:r>
-            <a:r>
-              <a:rPr sz="1200" b="0" i="0">
-                <a:solidFill>
-                  <a:srgbClr val="1D1D1D"/>
-                </a:solidFill>
-              </a:rPr>
-              <a:t>PDF → DeepSeek-OCR-2 → markdown → Jina v4 (dense vectors) → zerank-2 (reranker) → Top-5 text pages</a:t>
-            </a:r>
-          </a:p>
-        </p:txBody>
-      </p:sp>
-      <p:sp>
-        <p:nvSpPr>
-          <p:cNvPr id="38" name="TextBox 37"/>
-          <p:cNvSpPr txBox="1"/>
-          <p:nvPr/>
-        </p:nvSpPr>
-        <p:spPr>
-          <a:xfrm>
-            <a:off x="11295000" y="6395040"/>
-            <a:ext cx="9855000" cy="491040"/>
-          </a:xfrm>
-          <a:prstGeom prst="rect">
-            <a:avLst/>
-          </a:prstGeom>
-          <a:noFill/>
-        </p:spPr>
-        <p:txBody>
-          <a:bodyPr wrap="square">
-            <a:spAutoFit/>
-          </a:bodyPr>
-          <a:lstStyle/>
-          <a:p>
-            <a:r>
-              <a:rPr sz="1200" b="0" i="0">
-                <a:solidFill>
-                  <a:srgbClr val="C97B2C"/>
-                </a:solidFill>
-              </a:rPr>
-              <a:t>• </a:t>
-            </a:r>
-            <a:r>
-              <a:rPr sz="1200" b="1" i="0">
-                <a:solidFill>
-                  <a:srgbClr val="1D1D1D"/>
-                </a:solidFill>
-              </a:rPr>
-              <a:t>Image stream: </a:t>
-            </a:r>
-            <a:r>
-              <a:rPr sz="1200" b="0" i="0">
-                <a:solidFill>
-                  <a:srgbClr val="1D1D1D"/>
-                </a:solidFill>
-              </a:rPr>
-              <a:t>PDF page images → ColEmbed (image encoder) → Top-5 image pages</a:t>
-            </a:r>
-          </a:p>
-        </p:txBody>
-      </p:sp>
-      <p:sp>
-        <p:nvSpPr>
-          <p:cNvPr id="39" name="TextBox 38"/>
-          <p:cNvSpPr txBox="1"/>
-          <p:nvPr/>
-        </p:nvSpPr>
-        <p:spPr>
-          <a:xfrm>
-            <a:off x="11295000" y="6814080"/>
-            <a:ext cx="9855000" cy="491040"/>
-          </a:xfrm>
-          <a:prstGeom prst="rect">
-            <a:avLst/>
-          </a:prstGeom>
-          <a:noFill/>
-        </p:spPr>
-        <p:txBody>
-          <a:bodyPr wrap="square">
-            <a:spAutoFit/>
-          </a:bodyPr>
-          <a:lstStyle/>
-          <a:p>
-            <a:r>
-              <a:rPr sz="1200" b="0" i="0">
-                <a:solidFill>
-                  <a:srgbClr val="C97B2C"/>
-                </a:solidFill>
-              </a:rPr>
-              <a:t>• </a:t>
-            </a:r>
-            <a:r>
-              <a:rPr sz="1200" b="1" i="0">
-                <a:solidFill>
-                  <a:srgbClr val="1D1D1D"/>
-                </a:solidFill>
-              </a:rPr>
-              <a:t>Fusion + eval: </a:t>
-            </a:r>
-            <a:r>
-              <a:rPr sz="1200" b="0" i="0">
-                <a:solidFill>
-                  <a:srgbClr val="1D1D1D"/>
-                </a:solidFill>
-              </a:rPr>
-              <a:t>Top-5 text + Top-5 image → qwen3.5:35b (generator) → Answer → llama3.1:8b (judge) → pass@1</a:t>
-            </a:r>
-          </a:p>
-        </p:txBody>
-      </p:sp>
-      <p:sp>
-        <p:nvSpPr>
-          <p:cNvPr id="40" name="Rectangle 39"/>
+          <p:cNvPr id="37" name="Rectangle 36"/>
           <p:cNvSpPr/>
           <p:nvPr/>
         </p:nvSpPr>
         <p:spPr>
           <a:xfrm>
-            <a:off x="11223000" y="7359120"/>
-            <a:ext cx="72000" cy="324000"/>
+            <a:off x="14886535" y="6212357"/>
+            <a:ext cx="2599928" cy="661799"/>
           </a:xfrm>
           <a:prstGeom prst="rect">
             <a:avLst/>
           </a:prstGeom>
           <a:solidFill>
-            <a:srgbClr val="C97B2C"/>
+            <a:srgbClr val="FFFFFF"/>
           </a:solidFill>
-          <a:ln/>
+          <a:ln w="15240">
+            <a:solidFill>
+              <a:srgbClr val="1B3A6B"/>
+            </a:solidFill>
+          </a:ln>
         </p:spPr>
         <p:style>
           <a:lnRef idx="1">
@@ -4682,244 +4539,43 @@
           </a:fontRef>
         </p:style>
         <p:txBody>
-          <a:bodyPr rtlCol="0" anchor="ctr"/>
+          <a:bodyPr rtlCol="0" anchor="ctr" wrap="square"/>
           <a:lstStyle/>
           <a:p>
             <a:pPr algn="ctr"/>
-          </a:p>
-        </p:txBody>
-      </p:sp>
-      <p:sp>
-        <p:nvSpPr>
-          <p:cNvPr id="41" name="TextBox 40"/>
-          <p:cNvSpPr txBox="1"/>
-          <p:nvPr/>
-        </p:nvSpPr>
-        <p:spPr>
-          <a:xfrm>
-            <a:off x="11403000" y="7305120"/>
-            <a:ext cx="9747000" cy="432000"/>
-          </a:xfrm>
-          <a:prstGeom prst="rect">
-            <a:avLst/>
-          </a:prstGeom>
-          <a:noFill/>
-        </p:spPr>
-        <p:txBody>
-          <a:bodyPr wrap="square">
-            <a:spAutoFit/>
-          </a:bodyPr>
-          <a:lstStyle/>
-          <a:p>
-            <a:r>
-              <a:rPr sz="1500" b="1" i="0">
-                <a:solidFill>
-                  <a:srgbClr val="1B3A6B"/>
-                </a:solidFill>
-              </a:rPr>
-              <a:t>Model choices</a:t>
-            </a:r>
-          </a:p>
-        </p:txBody>
-      </p:sp>
-      <p:sp>
-        <p:nvSpPr>
-          <p:cNvPr id="42" name="TextBox 41"/>
-          <p:cNvSpPr txBox="1"/>
-          <p:nvPr/>
-        </p:nvSpPr>
-        <p:spPr>
-          <a:xfrm>
-            <a:off x="11295000" y="7773120"/>
-            <a:ext cx="9855000" cy="491040"/>
-          </a:xfrm>
-          <a:prstGeom prst="rect">
-            <a:avLst/>
-          </a:prstGeom>
-          <a:noFill/>
-        </p:spPr>
-        <p:txBody>
-          <a:bodyPr wrap="square">
-            <a:spAutoFit/>
-          </a:bodyPr>
-          <a:lstStyle/>
-          <a:p>
-            <a:r>
-              <a:rPr sz="1200" b="0" i="0">
-                <a:solidFill>
-                  <a:srgbClr val="C97B2C"/>
-                </a:solidFill>
-              </a:rPr>
-              <a:t>• </a:t>
-            </a:r>
-            <a:r>
-              <a:rPr sz="1200" b="1" i="0">
+            <a:r>
+              <a:rPr sz="900" b="1" i="0">
                 <a:solidFill>
                   <a:srgbClr val="1D1D1D"/>
                 </a:solidFill>
               </a:rPr>
-              <a:t>DeepSeek-OCR-2: </a:t>
-            </a:r>
-            <a:r>
-              <a:rPr sz="1200" b="0" i="0">
-                <a:solidFill>
-                  <a:srgbClr val="1D1D1D"/>
-                </a:solidFill>
-              </a:rPr>
-              <a:t>open-weights document OCR with layout-preserving markdown (HTML tables, LaTeX)</a:t>
-            </a:r>
-          </a:p>
-        </p:txBody>
-      </p:sp>
-      <p:sp>
-        <p:nvSpPr>
-          <p:cNvPr id="43" name="TextBox 42"/>
-          <p:cNvSpPr txBox="1"/>
-          <p:nvPr/>
-        </p:nvSpPr>
-        <p:spPr>
-          <a:xfrm>
-            <a:off x="11295000" y="8192160"/>
-            <a:ext cx="9855000" cy="491040"/>
-          </a:xfrm>
-          <a:prstGeom prst="rect">
-            <a:avLst/>
-          </a:prstGeom>
-          <a:noFill/>
-        </p:spPr>
-        <p:txBody>
-          <a:bodyPr wrap="square">
-            <a:spAutoFit/>
-          </a:bodyPr>
-          <a:lstStyle/>
-          <a:p>
-            <a:r>
-              <a:rPr sz="1200" b="0" i="0">
-                <a:solidFill>
-                  <a:srgbClr val="C97B2C"/>
-                </a:solidFill>
-              </a:rPr>
-              <a:t>• </a:t>
-            </a:r>
-            <a:r>
-              <a:rPr sz="1200" b="1" i="0">
-                <a:solidFill>
-                  <a:srgbClr val="1D1D1D"/>
-                </a:solidFill>
-              </a:rPr>
-              <a:t>qwen3.5:35b: </a:t>
-            </a:r>
-            <a:r>
-              <a:rPr sz="1200" b="0" i="0">
-                <a:solidFill>
-                  <a:srgbClr val="1D1D1D"/>
-                </a:solidFill>
-              </a:rPr>
-              <a:t>multimodal generator, Q4-quantized MoE, fits on one 48 GB GPU, 262k context</a:t>
-            </a:r>
-          </a:p>
-        </p:txBody>
-      </p:sp>
-      <p:sp>
-        <p:nvSpPr>
-          <p:cNvPr id="44" name="TextBox 43"/>
-          <p:cNvSpPr txBox="1"/>
-          <p:nvPr/>
-        </p:nvSpPr>
-        <p:spPr>
-          <a:xfrm>
-            <a:off x="11295000" y="8611200"/>
-            <a:ext cx="9855000" cy="491040"/>
-          </a:xfrm>
-          <a:prstGeom prst="rect">
-            <a:avLst/>
-          </a:prstGeom>
-          <a:noFill/>
-        </p:spPr>
-        <p:txBody>
-          <a:bodyPr wrap="square">
-            <a:spAutoFit/>
-          </a:bodyPr>
-          <a:lstStyle/>
-          <a:p>
-            <a:r>
-              <a:rPr sz="1200" b="0" i="0">
-                <a:solidFill>
-                  <a:srgbClr val="C97B2C"/>
-                </a:solidFill>
-              </a:rPr>
-              <a:t>• </a:t>
-            </a:r>
-            <a:r>
-              <a:rPr sz="1200" b="1" i="0">
-                <a:solidFill>
-                  <a:srgbClr val="1D1D1D"/>
-                </a:solidFill>
-              </a:rPr>
-              <a:t>llama3.1:8b: </a:t>
-            </a:r>
-            <a:r>
-              <a:rPr sz="1200" b="0" i="0">
-                <a:solidFill>
-                  <a:srgbClr val="1D1D1D"/>
-                </a:solidFill>
-              </a:rPr>
-              <a:t>judge from a different model family (Meta vs Alibaba) to reduce self-preference bias</a:t>
-            </a:r>
-          </a:p>
-        </p:txBody>
-      </p:sp>
-      <p:sp>
-        <p:nvSpPr>
-          <p:cNvPr id="45" name="TextBox 44"/>
-          <p:cNvSpPr txBox="1"/>
-          <p:nvPr/>
-        </p:nvSpPr>
-        <p:spPr>
-          <a:xfrm>
-            <a:off x="11223000" y="9102240"/>
-            <a:ext cx="9927000" cy="432000"/>
-          </a:xfrm>
-          <a:prstGeom prst="rect">
-            <a:avLst/>
-          </a:prstGeom>
-          <a:noFill/>
-        </p:spPr>
-        <p:txBody>
-          <a:bodyPr wrap="square">
-            <a:spAutoFit/>
-          </a:bodyPr>
-          <a:lstStyle/>
-          <a:p>
-            <a:r>
-              <a:rPr sz="1100" b="0" i="0">
-                <a:solidFill>
-                  <a:srgbClr val="666666"/>
-                </a:solidFill>
-              </a:rPr>
-              <a:t>All components are open-weights and run on a single GPU.</a:t>
-            </a:r>
-          </a:p>
-        </p:txBody>
-      </p:sp>
-      <p:sp>
-        <p:nvSpPr>
-          <p:cNvPr id="46" name="Rectangle 45"/>
+              <a:t>PDF page image</a:t>
+            </a:r>
+          </a:p>
+        </p:txBody>
+      </p:sp>
+      <p:sp>
+        <p:nvSpPr>
+          <p:cNvPr id="38" name="Rectangle 37"/>
           <p:cNvSpPr/>
           <p:nvPr/>
         </p:nvSpPr>
         <p:spPr>
           <a:xfrm>
-            <a:off x="11223000" y="9660240"/>
-            <a:ext cx="72000" cy="324000"/>
+            <a:off x="11695714" y="7630499"/>
+            <a:ext cx="3545357" cy="803614"/>
           </a:xfrm>
           <a:prstGeom prst="rect">
             <a:avLst/>
           </a:prstGeom>
           <a:solidFill>
-            <a:srgbClr val="C97B2C"/>
+            <a:srgbClr val="FDF5E7"/>
           </a:solidFill>
-          <a:ln/>
+          <a:ln w="15240">
+            <a:solidFill>
+              <a:srgbClr val="C97B2C"/>
+            </a:solidFill>
+          </a:ln>
         </p:spPr>
         <p:style>
           <a:lnRef idx="1">
@@ -4936,6 +4592,915 @@
           </a:fontRef>
         </p:style>
         <p:txBody>
+          <a:bodyPr rtlCol="0" anchor="ctr" wrap="square"/>
+          <a:lstStyle/>
+          <a:p>
+            <a:pPr algn="ctr"/>
+            <a:r>
+              <a:rPr sz="900" b="1" i="0">
+                <a:solidFill>
+                  <a:srgbClr val="1D1D1D"/>
+                </a:solidFill>
+              </a:rPr>
+              <a:t>DeepSeek-OCR-2</a:t>
+            </a:r>
+          </a:p>
+          <a:p>
+            <a:pPr algn="ctr"/>
+            <a:r>
+              <a:rPr sz="700" b="0" i="0">
+                <a:solidFill>
+                  <a:srgbClr val="666666"/>
+                </a:solidFill>
+              </a:rPr>
+              <a:t>text extraction (fixed)</a:t>
+            </a:r>
+          </a:p>
+        </p:txBody>
+      </p:sp>
+      <p:sp>
+        <p:nvSpPr>
+          <p:cNvPr id="39" name="Rectangle 38"/>
+          <p:cNvSpPr/>
+          <p:nvPr/>
+        </p:nvSpPr>
+        <p:spPr>
+          <a:xfrm>
+            <a:off x="11695714" y="8812285"/>
+            <a:ext cx="3545357" cy="614528"/>
+          </a:xfrm>
+          <a:prstGeom prst="rect">
+            <a:avLst/>
+          </a:prstGeom>
+          <a:solidFill>
+            <a:srgbClr val="FFFFFF"/>
+          </a:solidFill>
+          <a:ln w="15240">
+            <a:solidFill>
+              <a:srgbClr val="1B3A6B"/>
+            </a:solidFill>
+          </a:ln>
+        </p:spPr>
+        <p:style>
+          <a:lnRef idx="1">
+            <a:schemeClr val="accent1"/>
+          </a:lnRef>
+          <a:fillRef idx="3">
+            <a:schemeClr val="accent1"/>
+          </a:fillRef>
+          <a:effectRef idx="2">
+            <a:schemeClr val="accent1"/>
+          </a:effectRef>
+          <a:fontRef idx="minor">
+            <a:schemeClr val="lt1"/>
+          </a:fontRef>
+        </p:style>
+        <p:txBody>
+          <a:bodyPr rtlCol="0" anchor="ctr" wrap="square"/>
+          <a:lstStyle/>
+          <a:p>
+            <a:pPr algn="ctr"/>
+            <a:r>
+              <a:rPr sz="900" b="1" i="0">
+                <a:solidFill>
+                  <a:srgbClr val="1D1D1D"/>
+                </a:solidFill>
+              </a:rPr>
+              <a:t>Jina v4</a:t>
+            </a:r>
+          </a:p>
+          <a:p>
+            <a:pPr algn="ctr"/>
+            <a:r>
+              <a:rPr sz="700" b="0" i="0">
+                <a:solidFill>
+                  <a:srgbClr val="666666"/>
+                </a:solidFill>
+              </a:rPr>
+              <a:t>text encoder</a:t>
+            </a:r>
+          </a:p>
+        </p:txBody>
+      </p:sp>
+      <p:sp>
+        <p:nvSpPr>
+          <p:cNvPr id="40" name="Rectangle 39"/>
+          <p:cNvSpPr/>
+          <p:nvPr/>
+        </p:nvSpPr>
+        <p:spPr>
+          <a:xfrm>
+            <a:off x="11695714" y="9757713"/>
+            <a:ext cx="3545357" cy="614528"/>
+          </a:xfrm>
+          <a:prstGeom prst="rect">
+            <a:avLst/>
+          </a:prstGeom>
+          <a:solidFill>
+            <a:srgbClr val="FFFFFF"/>
+          </a:solidFill>
+          <a:ln w="15240">
+            <a:solidFill>
+              <a:srgbClr val="1B3A6B"/>
+            </a:solidFill>
+          </a:ln>
+        </p:spPr>
+        <p:style>
+          <a:lnRef idx="1">
+            <a:schemeClr val="accent1"/>
+          </a:lnRef>
+          <a:fillRef idx="3">
+            <a:schemeClr val="accent1"/>
+          </a:fillRef>
+          <a:effectRef idx="2">
+            <a:schemeClr val="accent1"/>
+          </a:effectRef>
+          <a:fontRef idx="minor">
+            <a:schemeClr val="lt1"/>
+          </a:fontRef>
+        </p:style>
+        <p:txBody>
+          <a:bodyPr rtlCol="0" anchor="ctr" wrap="square"/>
+          <a:lstStyle/>
+          <a:p>
+            <a:pPr algn="ctr"/>
+            <a:r>
+              <a:rPr sz="900" b="1" i="0">
+                <a:solidFill>
+                  <a:srgbClr val="1D1D1D"/>
+                </a:solidFill>
+              </a:rPr>
+              <a:t>zerank-2</a:t>
+            </a:r>
+          </a:p>
+          <a:p>
+            <a:pPr algn="ctr"/>
+            <a:r>
+              <a:rPr sz="700" b="0" i="0">
+                <a:solidFill>
+                  <a:srgbClr val="666666"/>
+                </a:solidFill>
+              </a:rPr>
+              <a:t>cross-encoder reranker</a:t>
+            </a:r>
+          </a:p>
+        </p:txBody>
+      </p:sp>
+      <p:sp>
+        <p:nvSpPr>
+          <p:cNvPr id="41" name="Rectangle 40"/>
+          <p:cNvSpPr/>
+          <p:nvPr/>
+        </p:nvSpPr>
+        <p:spPr>
+          <a:xfrm>
+            <a:off x="11695714" y="10703142"/>
+            <a:ext cx="3545357" cy="614528"/>
+          </a:xfrm>
+          <a:prstGeom prst="rect">
+            <a:avLst/>
+          </a:prstGeom>
+          <a:solidFill>
+            <a:srgbClr val="FFFFFF"/>
+          </a:solidFill>
+          <a:ln w="15240">
+            <a:solidFill>
+              <a:srgbClr val="1B3A6B"/>
+            </a:solidFill>
+          </a:ln>
+        </p:spPr>
+        <p:style>
+          <a:lnRef idx="1">
+            <a:schemeClr val="accent1"/>
+          </a:lnRef>
+          <a:fillRef idx="3">
+            <a:schemeClr val="accent1"/>
+          </a:fillRef>
+          <a:effectRef idx="2">
+            <a:schemeClr val="accent1"/>
+          </a:effectRef>
+          <a:fontRef idx="minor">
+            <a:schemeClr val="lt1"/>
+          </a:fontRef>
+        </p:style>
+        <p:txBody>
+          <a:bodyPr rtlCol="0" anchor="ctr" wrap="square"/>
+          <a:lstStyle/>
+          <a:p>
+            <a:pPr algn="ctr"/>
+            <a:r>
+              <a:rPr sz="900" b="1" i="0">
+                <a:solidFill>
+                  <a:srgbClr val="1D1D1D"/>
+                </a:solidFill>
+              </a:rPr>
+              <a:t>Top-5 text docs</a:t>
+            </a:r>
+          </a:p>
+        </p:txBody>
+      </p:sp>
+      <p:sp>
+        <p:nvSpPr>
+          <p:cNvPr id="42" name="Rectangle 41"/>
+          <p:cNvSpPr/>
+          <p:nvPr/>
+        </p:nvSpPr>
+        <p:spPr>
+          <a:xfrm>
+            <a:off x="17131928" y="7630499"/>
+            <a:ext cx="3545357" cy="614528"/>
+          </a:xfrm>
+          <a:prstGeom prst="rect">
+            <a:avLst/>
+          </a:prstGeom>
+          <a:solidFill>
+            <a:srgbClr val="FFFFFF"/>
+          </a:solidFill>
+          <a:ln w="15240">
+            <a:solidFill>
+              <a:srgbClr val="1B3A6B"/>
+            </a:solidFill>
+          </a:ln>
+        </p:spPr>
+        <p:style>
+          <a:lnRef idx="1">
+            <a:schemeClr val="accent1"/>
+          </a:lnRef>
+          <a:fillRef idx="3">
+            <a:schemeClr val="accent1"/>
+          </a:fillRef>
+          <a:effectRef idx="2">
+            <a:schemeClr val="accent1"/>
+          </a:effectRef>
+          <a:fontRef idx="minor">
+            <a:schemeClr val="lt1"/>
+          </a:fontRef>
+        </p:style>
+        <p:txBody>
+          <a:bodyPr rtlCol="0" anchor="ctr" wrap="square"/>
+          <a:lstStyle/>
+          <a:p>
+            <a:pPr algn="ctr"/>
+            <a:r>
+              <a:rPr sz="900" b="1" i="0">
+                <a:solidFill>
+                  <a:srgbClr val="1D1D1D"/>
+                </a:solidFill>
+              </a:rPr>
+              <a:t>Page images</a:t>
+            </a:r>
+          </a:p>
+        </p:txBody>
+      </p:sp>
+      <p:sp>
+        <p:nvSpPr>
+          <p:cNvPr id="43" name="Rectangle 42"/>
+          <p:cNvSpPr/>
+          <p:nvPr/>
+        </p:nvSpPr>
+        <p:spPr>
+          <a:xfrm>
+            <a:off x="17131928" y="9757713"/>
+            <a:ext cx="3545357" cy="614528"/>
+          </a:xfrm>
+          <a:prstGeom prst="rect">
+            <a:avLst/>
+          </a:prstGeom>
+          <a:solidFill>
+            <a:srgbClr val="FFFFFF"/>
+          </a:solidFill>
+          <a:ln w="15240">
+            <a:solidFill>
+              <a:srgbClr val="1B3A6B"/>
+            </a:solidFill>
+          </a:ln>
+        </p:spPr>
+        <p:style>
+          <a:lnRef idx="1">
+            <a:schemeClr val="accent1"/>
+          </a:lnRef>
+          <a:fillRef idx="3">
+            <a:schemeClr val="accent1"/>
+          </a:fillRef>
+          <a:effectRef idx="2">
+            <a:schemeClr val="accent1"/>
+          </a:effectRef>
+          <a:fontRef idx="minor">
+            <a:schemeClr val="lt1"/>
+          </a:fontRef>
+        </p:style>
+        <p:txBody>
+          <a:bodyPr rtlCol="0" anchor="ctr" wrap="square"/>
+          <a:lstStyle/>
+          <a:p>
+            <a:pPr algn="ctr"/>
+            <a:r>
+              <a:rPr sz="900" b="1" i="0">
+                <a:solidFill>
+                  <a:srgbClr val="1D1D1D"/>
+                </a:solidFill>
+              </a:rPr>
+              <a:t>ColEmbed</a:t>
+            </a:r>
+          </a:p>
+          <a:p>
+            <a:pPr algn="ctr"/>
+            <a:r>
+              <a:rPr sz="700" b="0" i="0">
+                <a:solidFill>
+                  <a:srgbClr val="666666"/>
+                </a:solidFill>
+              </a:rPr>
+              <a:t>image encoder</a:t>
+            </a:r>
+          </a:p>
+        </p:txBody>
+      </p:sp>
+      <p:sp>
+        <p:nvSpPr>
+          <p:cNvPr id="44" name="Rectangle 43"/>
+          <p:cNvSpPr/>
+          <p:nvPr/>
+        </p:nvSpPr>
+        <p:spPr>
+          <a:xfrm>
+            <a:off x="17131928" y="10703142"/>
+            <a:ext cx="3545357" cy="614528"/>
+          </a:xfrm>
+          <a:prstGeom prst="rect">
+            <a:avLst/>
+          </a:prstGeom>
+          <a:solidFill>
+            <a:srgbClr val="FFFFFF"/>
+          </a:solidFill>
+          <a:ln w="15240">
+            <a:solidFill>
+              <a:srgbClr val="1B3A6B"/>
+            </a:solidFill>
+          </a:ln>
+        </p:spPr>
+        <p:style>
+          <a:lnRef idx="1">
+            <a:schemeClr val="accent1"/>
+          </a:lnRef>
+          <a:fillRef idx="3">
+            <a:schemeClr val="accent1"/>
+          </a:fillRef>
+          <a:effectRef idx="2">
+            <a:schemeClr val="accent1"/>
+          </a:effectRef>
+          <a:fontRef idx="minor">
+            <a:schemeClr val="lt1"/>
+          </a:fontRef>
+        </p:style>
+        <p:txBody>
+          <a:bodyPr rtlCol="0" anchor="ctr" wrap="square"/>
+          <a:lstStyle/>
+          <a:p>
+            <a:pPr algn="ctr"/>
+            <a:r>
+              <a:rPr sz="900" b="1" i="0">
+                <a:solidFill>
+                  <a:srgbClr val="1D1D1D"/>
+                </a:solidFill>
+              </a:rPr>
+              <a:t>Top-5 image pages</a:t>
+            </a:r>
+          </a:p>
+        </p:txBody>
+      </p:sp>
+      <p:sp>
+        <p:nvSpPr>
+          <p:cNvPr id="45" name="Rectangle 44"/>
+          <p:cNvSpPr/>
+          <p:nvPr/>
+        </p:nvSpPr>
+        <p:spPr>
+          <a:xfrm>
+            <a:off x="14413821" y="11955835"/>
+            <a:ext cx="3545357" cy="709071"/>
+          </a:xfrm>
+          <a:prstGeom prst="rect">
+            <a:avLst/>
+          </a:prstGeom>
+          <a:solidFill>
+            <a:srgbClr val="FDF5E7"/>
+          </a:solidFill>
+          <a:ln w="15240">
+            <a:solidFill>
+              <a:srgbClr val="C97B2C"/>
+            </a:solidFill>
+          </a:ln>
+        </p:spPr>
+        <p:style>
+          <a:lnRef idx="1">
+            <a:schemeClr val="accent1"/>
+          </a:lnRef>
+          <a:fillRef idx="3">
+            <a:schemeClr val="accent1"/>
+          </a:fillRef>
+          <a:effectRef idx="2">
+            <a:schemeClr val="accent1"/>
+          </a:effectRef>
+          <a:fontRef idx="minor">
+            <a:schemeClr val="lt1"/>
+          </a:fontRef>
+        </p:style>
+        <p:txBody>
+          <a:bodyPr rtlCol="0" anchor="ctr" wrap="square"/>
+          <a:lstStyle/>
+          <a:p>
+            <a:pPr algn="ctr"/>
+            <a:r>
+              <a:rPr sz="900" b="1" i="0">
+                <a:solidFill>
+                  <a:srgbClr val="1D1D1D"/>
+                </a:solidFill>
+              </a:rPr>
+              <a:t>qwen3.5:35b</a:t>
+            </a:r>
+          </a:p>
+          <a:p>
+            <a:pPr algn="ctr"/>
+            <a:r>
+              <a:rPr sz="700" b="0" i="0">
+                <a:solidFill>
+                  <a:srgbClr val="666666"/>
+                </a:solidFill>
+              </a:rPr>
+              <a:t>multimodal generator</a:t>
+            </a:r>
+          </a:p>
+        </p:txBody>
+      </p:sp>
+      <p:sp>
+        <p:nvSpPr>
+          <p:cNvPr id="46" name="Rectangle 45"/>
+          <p:cNvSpPr/>
+          <p:nvPr/>
+        </p:nvSpPr>
+        <p:spPr>
+          <a:xfrm>
+            <a:off x="14413821" y="13113984"/>
+            <a:ext cx="3545357" cy="614528"/>
+          </a:xfrm>
+          <a:prstGeom prst="rect">
+            <a:avLst/>
+          </a:prstGeom>
+          <a:solidFill>
+            <a:srgbClr val="FDF5E7"/>
+          </a:solidFill>
+          <a:ln w="15240">
+            <a:solidFill>
+              <a:srgbClr val="C97B2C"/>
+            </a:solidFill>
+          </a:ln>
+        </p:spPr>
+        <p:style>
+          <a:lnRef idx="1">
+            <a:schemeClr val="accent1"/>
+          </a:lnRef>
+          <a:fillRef idx="3">
+            <a:schemeClr val="accent1"/>
+          </a:fillRef>
+          <a:effectRef idx="2">
+            <a:schemeClr val="accent1"/>
+          </a:effectRef>
+          <a:fontRef idx="minor">
+            <a:schemeClr val="lt1"/>
+          </a:fontRef>
+        </p:style>
+        <p:txBody>
+          <a:bodyPr rtlCol="0" anchor="ctr" wrap="square"/>
+          <a:lstStyle/>
+          <a:p>
+            <a:pPr algn="ctr"/>
+            <a:r>
+              <a:rPr sz="900" b="1" i="0">
+                <a:solidFill>
+                  <a:srgbClr val="1D1D1D"/>
+                </a:solidFill>
+              </a:rPr>
+              <a:t>llama3.1:8b</a:t>
+            </a:r>
+          </a:p>
+          <a:p>
+            <a:pPr algn="ctr"/>
+            <a:r>
+              <a:rPr sz="700" b="0" i="0">
+                <a:solidFill>
+                  <a:srgbClr val="666666"/>
+                </a:solidFill>
+              </a:rPr>
+              <a:t>judge</a:t>
+            </a:r>
+          </a:p>
+        </p:txBody>
+      </p:sp>
+      <p:cxnSp>
+        <p:nvCxnSpPr>
+          <p:cNvPr id="47" name="Connector 46"/>
+          <p:cNvCxnSpPr/>
+          <p:nvPr/>
+        </p:nvCxnSpPr>
+        <p:spPr>
+          <a:xfrm flipH="1">
+            <a:off x="13468392" y="6874157"/>
+            <a:ext cx="2009036" cy="756342"/>
+          </a:xfrm>
+          <a:prstGeom prst="line">
+            <a:avLst/>
+          </a:prstGeom>
+          <a:ln w="15240">
+            <a:solidFill>
+              <a:srgbClr val="1b3a6b"/>
+            </a:solidFill>
+            <a:headEnd type="none"/>
+            <a:tailEnd type="arrow" w="med" len="med"/>
+          </a:ln>
+        </p:spPr>
+        <p:style>
+          <a:lnRef idx="2">
+            <a:schemeClr val="accent1"/>
+          </a:lnRef>
+          <a:fillRef idx="0">
+            <a:schemeClr val="accent1"/>
+          </a:fillRef>
+          <a:effectRef idx="1">
+            <a:schemeClr val="accent1"/>
+          </a:effectRef>
+          <a:fontRef idx="minor">
+            <a:schemeClr val="tx1"/>
+          </a:fontRef>
+        </p:style>
+      </p:cxnSp>
+      <p:cxnSp>
+        <p:nvCxnSpPr>
+          <p:cNvPr id="48" name="Connector 47"/>
+          <p:cNvCxnSpPr/>
+          <p:nvPr/>
+        </p:nvCxnSpPr>
+        <p:spPr>
+          <a:xfrm>
+            <a:off x="16895571" y="6874157"/>
+            <a:ext cx="2009036" cy="756342"/>
+          </a:xfrm>
+          <a:prstGeom prst="line">
+            <a:avLst/>
+          </a:prstGeom>
+          <a:ln w="15240">
+            <a:solidFill>
+              <a:srgbClr val="1b3a6b"/>
+            </a:solidFill>
+            <a:headEnd type="none"/>
+            <a:tailEnd type="arrow" w="med" len="med"/>
+          </a:ln>
+        </p:spPr>
+        <p:style>
+          <a:lnRef idx="2">
+            <a:schemeClr val="accent1"/>
+          </a:lnRef>
+          <a:fillRef idx="0">
+            <a:schemeClr val="accent1"/>
+          </a:fillRef>
+          <a:effectRef idx="1">
+            <a:schemeClr val="accent1"/>
+          </a:effectRef>
+          <a:fontRef idx="minor">
+            <a:schemeClr val="tx1"/>
+          </a:fontRef>
+        </p:style>
+      </p:cxnSp>
+      <p:cxnSp>
+        <p:nvCxnSpPr>
+          <p:cNvPr id="49" name="Connector 48"/>
+          <p:cNvCxnSpPr/>
+          <p:nvPr/>
+        </p:nvCxnSpPr>
+        <p:spPr>
+          <a:xfrm>
+            <a:off x="13468392" y="8434114"/>
+            <a:ext cx="0" cy="378171"/>
+          </a:xfrm>
+          <a:prstGeom prst="line">
+            <a:avLst/>
+          </a:prstGeom>
+          <a:ln w="15240">
+            <a:solidFill>
+              <a:srgbClr val="1b3a6b"/>
+            </a:solidFill>
+            <a:headEnd type="none"/>
+            <a:tailEnd type="arrow" w="med" len="med"/>
+          </a:ln>
+        </p:spPr>
+        <p:style>
+          <a:lnRef idx="2">
+            <a:schemeClr val="accent1"/>
+          </a:lnRef>
+          <a:fillRef idx="0">
+            <a:schemeClr val="accent1"/>
+          </a:fillRef>
+          <a:effectRef idx="1">
+            <a:schemeClr val="accent1"/>
+          </a:effectRef>
+          <a:fontRef idx="minor">
+            <a:schemeClr val="tx1"/>
+          </a:fontRef>
+        </p:style>
+      </p:cxnSp>
+      <p:cxnSp>
+        <p:nvCxnSpPr>
+          <p:cNvPr id="50" name="Connector 49"/>
+          <p:cNvCxnSpPr/>
+          <p:nvPr/>
+        </p:nvCxnSpPr>
+        <p:spPr>
+          <a:xfrm>
+            <a:off x="13468392" y="9426813"/>
+            <a:ext cx="0" cy="330900"/>
+          </a:xfrm>
+          <a:prstGeom prst="line">
+            <a:avLst/>
+          </a:prstGeom>
+          <a:ln w="15240">
+            <a:solidFill>
+              <a:srgbClr val="1b3a6b"/>
+            </a:solidFill>
+            <a:headEnd type="none"/>
+            <a:tailEnd type="arrow" w="med" len="med"/>
+          </a:ln>
+        </p:spPr>
+        <p:style>
+          <a:lnRef idx="2">
+            <a:schemeClr val="accent1"/>
+          </a:lnRef>
+          <a:fillRef idx="0">
+            <a:schemeClr val="accent1"/>
+          </a:fillRef>
+          <a:effectRef idx="1">
+            <a:schemeClr val="accent1"/>
+          </a:effectRef>
+          <a:fontRef idx="minor">
+            <a:schemeClr val="tx1"/>
+          </a:fontRef>
+        </p:style>
+      </p:cxnSp>
+      <p:cxnSp>
+        <p:nvCxnSpPr>
+          <p:cNvPr id="51" name="Connector 50"/>
+          <p:cNvCxnSpPr/>
+          <p:nvPr/>
+        </p:nvCxnSpPr>
+        <p:spPr>
+          <a:xfrm>
+            <a:off x="13468392" y="10372242"/>
+            <a:ext cx="0" cy="330900"/>
+          </a:xfrm>
+          <a:prstGeom prst="line">
+            <a:avLst/>
+          </a:prstGeom>
+          <a:ln w="15240">
+            <a:solidFill>
+              <a:srgbClr val="1b3a6b"/>
+            </a:solidFill>
+            <a:headEnd type="none"/>
+            <a:tailEnd type="arrow" w="med" len="med"/>
+          </a:ln>
+        </p:spPr>
+        <p:style>
+          <a:lnRef idx="2">
+            <a:schemeClr val="accent1"/>
+          </a:lnRef>
+          <a:fillRef idx="0">
+            <a:schemeClr val="accent1"/>
+          </a:fillRef>
+          <a:effectRef idx="1">
+            <a:schemeClr val="accent1"/>
+          </a:effectRef>
+          <a:fontRef idx="minor">
+            <a:schemeClr val="tx1"/>
+          </a:fontRef>
+        </p:style>
+      </p:cxnSp>
+      <p:cxnSp>
+        <p:nvCxnSpPr>
+          <p:cNvPr id="52" name="Connector 51"/>
+          <p:cNvCxnSpPr/>
+          <p:nvPr/>
+        </p:nvCxnSpPr>
+        <p:spPr>
+          <a:xfrm>
+            <a:off x="18904607" y="8245028"/>
+            <a:ext cx="0" cy="1512685"/>
+          </a:xfrm>
+          <a:prstGeom prst="line">
+            <a:avLst/>
+          </a:prstGeom>
+          <a:ln w="15240">
+            <a:solidFill>
+              <a:srgbClr val="1b3a6b"/>
+            </a:solidFill>
+            <a:headEnd type="none"/>
+            <a:tailEnd type="arrow" w="med" len="med"/>
+          </a:ln>
+        </p:spPr>
+        <p:style>
+          <a:lnRef idx="2">
+            <a:schemeClr val="accent1"/>
+          </a:lnRef>
+          <a:fillRef idx="0">
+            <a:schemeClr val="accent1"/>
+          </a:fillRef>
+          <a:effectRef idx="1">
+            <a:schemeClr val="accent1"/>
+          </a:effectRef>
+          <a:fontRef idx="minor">
+            <a:schemeClr val="tx1"/>
+          </a:fontRef>
+        </p:style>
+      </p:cxnSp>
+      <p:cxnSp>
+        <p:nvCxnSpPr>
+          <p:cNvPr id="53" name="Connector 52"/>
+          <p:cNvCxnSpPr/>
+          <p:nvPr/>
+        </p:nvCxnSpPr>
+        <p:spPr>
+          <a:xfrm>
+            <a:off x="18904607" y="10372242"/>
+            <a:ext cx="0" cy="330900"/>
+          </a:xfrm>
+          <a:prstGeom prst="line">
+            <a:avLst/>
+          </a:prstGeom>
+          <a:ln w="15240">
+            <a:solidFill>
+              <a:srgbClr val="1b3a6b"/>
+            </a:solidFill>
+            <a:headEnd type="none"/>
+            <a:tailEnd type="arrow" w="med" len="med"/>
+          </a:ln>
+        </p:spPr>
+        <p:style>
+          <a:lnRef idx="2">
+            <a:schemeClr val="accent1"/>
+          </a:lnRef>
+          <a:fillRef idx="0">
+            <a:schemeClr val="accent1"/>
+          </a:fillRef>
+          <a:effectRef idx="1">
+            <a:schemeClr val="accent1"/>
+          </a:effectRef>
+          <a:fontRef idx="minor">
+            <a:schemeClr val="tx1"/>
+          </a:fontRef>
+        </p:style>
+      </p:cxnSp>
+      <p:cxnSp>
+        <p:nvCxnSpPr>
+          <p:cNvPr id="54" name="Connector 53"/>
+          <p:cNvCxnSpPr/>
+          <p:nvPr/>
+        </p:nvCxnSpPr>
+        <p:spPr>
+          <a:xfrm>
+            <a:off x="14295642" y="11317670"/>
+            <a:ext cx="1181786" cy="567257"/>
+          </a:xfrm>
+          <a:prstGeom prst="line">
+            <a:avLst/>
+          </a:prstGeom>
+          <a:ln w="15240">
+            <a:solidFill>
+              <a:srgbClr val="1b3a6b"/>
+            </a:solidFill>
+            <a:headEnd type="none"/>
+            <a:tailEnd type="arrow" w="med" len="med"/>
+          </a:ln>
+        </p:spPr>
+        <p:style>
+          <a:lnRef idx="2">
+            <a:schemeClr val="accent1"/>
+          </a:lnRef>
+          <a:fillRef idx="0">
+            <a:schemeClr val="accent1"/>
+          </a:fillRef>
+          <a:effectRef idx="1">
+            <a:schemeClr val="accent1"/>
+          </a:effectRef>
+          <a:fontRef idx="minor">
+            <a:schemeClr val="tx1"/>
+          </a:fontRef>
+        </p:style>
+      </p:cxnSp>
+      <p:cxnSp>
+        <p:nvCxnSpPr>
+          <p:cNvPr id="55" name="Connector 54"/>
+          <p:cNvCxnSpPr/>
+          <p:nvPr/>
+        </p:nvCxnSpPr>
+        <p:spPr>
+          <a:xfrm flipH="1">
+            <a:off x="16895571" y="11317670"/>
+            <a:ext cx="1181786" cy="567257"/>
+          </a:xfrm>
+          <a:prstGeom prst="line">
+            <a:avLst/>
+          </a:prstGeom>
+          <a:ln w="15240">
+            <a:solidFill>
+              <a:srgbClr val="1b3a6b"/>
+            </a:solidFill>
+            <a:headEnd type="none"/>
+            <a:tailEnd type="arrow" w="med" len="med"/>
+          </a:ln>
+        </p:spPr>
+        <p:style>
+          <a:lnRef idx="2">
+            <a:schemeClr val="accent1"/>
+          </a:lnRef>
+          <a:fillRef idx="0">
+            <a:schemeClr val="accent1"/>
+          </a:fillRef>
+          <a:effectRef idx="1">
+            <a:schemeClr val="accent1"/>
+          </a:effectRef>
+          <a:fontRef idx="minor">
+            <a:schemeClr val="tx1"/>
+          </a:fontRef>
+        </p:style>
+      </p:cxnSp>
+      <p:cxnSp>
+        <p:nvCxnSpPr>
+          <p:cNvPr id="56" name="Connector 55"/>
+          <p:cNvCxnSpPr/>
+          <p:nvPr/>
+        </p:nvCxnSpPr>
+        <p:spPr>
+          <a:xfrm>
+            <a:off x="16186500" y="12664906"/>
+            <a:ext cx="0" cy="449078"/>
+          </a:xfrm>
+          <a:prstGeom prst="line">
+            <a:avLst/>
+          </a:prstGeom>
+          <a:ln w="15240">
+            <a:solidFill>
+              <a:srgbClr val="1b3a6b"/>
+            </a:solidFill>
+            <a:headEnd type="none"/>
+            <a:tailEnd type="arrow" w="med" len="med"/>
+          </a:ln>
+        </p:spPr>
+        <p:style>
+          <a:lnRef idx="2">
+            <a:schemeClr val="accent1"/>
+          </a:lnRef>
+          <a:fillRef idx="0">
+            <a:schemeClr val="accent1"/>
+          </a:fillRef>
+          <a:effectRef idx="1">
+            <a:schemeClr val="accent1"/>
+          </a:effectRef>
+          <a:fontRef idx="minor">
+            <a:schemeClr val="tx1"/>
+          </a:fontRef>
+        </p:style>
+      </p:cxnSp>
+      <p:sp>
+        <p:nvSpPr>
+          <p:cNvPr id="57" name="Rectangle 56"/>
+          <p:cNvSpPr/>
+          <p:nvPr/>
+        </p:nvSpPr>
+        <p:spPr>
+          <a:xfrm>
+            <a:off x="11223000" y="14210142"/>
+            <a:ext cx="72000" cy="324000"/>
+          </a:xfrm>
+          <a:prstGeom prst="rect">
+            <a:avLst/>
+          </a:prstGeom>
+          <a:solidFill>
+            <a:srgbClr val="C97B2C"/>
+          </a:solidFill>
+          <a:ln/>
+        </p:spPr>
+        <p:style>
+          <a:lnRef idx="1">
+            <a:schemeClr val="accent1"/>
+          </a:lnRef>
+          <a:fillRef idx="3">
+            <a:schemeClr val="accent1"/>
+          </a:fillRef>
+          <a:effectRef idx="2">
+            <a:schemeClr val="accent1"/>
+          </a:effectRef>
+          <a:fontRef idx="minor">
+            <a:schemeClr val="lt1"/>
+          </a:fontRef>
+        </p:style>
+        <p:txBody>
           <a:bodyPr rtlCol="0" anchor="ctr"/>
           <a:lstStyle/>
           <a:p>
@@ -4945,13 +5510,13 @@
       </p:sp>
       <p:sp>
         <p:nvSpPr>
-          <p:cNvPr id="47" name="TextBox 46"/>
+          <p:cNvPr id="58" name="TextBox 57"/>
           <p:cNvSpPr txBox="1"/>
           <p:nvPr/>
         </p:nvSpPr>
         <p:spPr>
           <a:xfrm>
-            <a:off x="11403000" y="9606240"/>
+            <a:off x="11403000" y="14156142"/>
             <a:ext cx="9747000" cy="432000"/>
           </a:xfrm>
           <a:prstGeom prst="rect">
@@ -4971,21 +5536,21 @@
                   <a:srgbClr val="1B3A6B"/>
                 </a:solidFill>
               </a:rPr>
-              <a:t>DeepSeek-OCR-2</a:t>
-            </a:r>
-          </a:p>
-        </p:txBody>
-      </p:sp>
-      <p:sp>
-        <p:nvSpPr>
-          <p:cNvPr id="48" name="TextBox 47"/>
+              <a:t>Model choices</a:t>
+            </a:r>
+          </a:p>
+        </p:txBody>
+      </p:sp>
+      <p:sp>
+        <p:nvSpPr>
+          <p:cNvPr id="59" name="TextBox 58"/>
           <p:cNvSpPr txBox="1"/>
           <p:nvPr/>
         </p:nvSpPr>
         <p:spPr>
           <a:xfrm>
-            <a:off x="11223000" y="10074240"/>
-            <a:ext cx="9927000" cy="936000"/>
+            <a:off x="11295000" y="14624142"/>
+            <a:ext cx="9855000" cy="491040"/>
           </a:xfrm>
           <a:prstGeom prst="rect">
             <a:avLst/>
@@ -4999,6 +5564,260 @@
           <a:lstStyle/>
           <a:p>
             <a:r>
+              <a:rPr sz="1200" b="0" i="0">
+                <a:solidFill>
+                  <a:srgbClr val="C97B2C"/>
+                </a:solidFill>
+              </a:rPr>
+              <a:t>• </a:t>
+            </a:r>
+            <a:r>
+              <a:rPr sz="1200" b="1" i="0">
+                <a:solidFill>
+                  <a:srgbClr val="1D1D1D"/>
+                </a:solidFill>
+              </a:rPr>
+              <a:t>DeepSeek-OCR-2: </a:t>
+            </a:r>
+            <a:r>
+              <a:rPr sz="1200" b="0" i="0">
+                <a:solidFill>
+                  <a:srgbClr val="1D1D1D"/>
+                </a:solidFill>
+              </a:rPr>
+              <a:t>open-weights document OCR with layout-preserving markdown (HTML tables, LaTeX)</a:t>
+            </a:r>
+          </a:p>
+        </p:txBody>
+      </p:sp>
+      <p:sp>
+        <p:nvSpPr>
+          <p:cNvPr id="60" name="TextBox 59"/>
+          <p:cNvSpPr txBox="1"/>
+          <p:nvPr/>
+        </p:nvSpPr>
+        <p:spPr>
+          <a:xfrm>
+            <a:off x="11295000" y="15043182"/>
+            <a:ext cx="9855000" cy="491040"/>
+          </a:xfrm>
+          <a:prstGeom prst="rect">
+            <a:avLst/>
+          </a:prstGeom>
+          <a:noFill/>
+        </p:spPr>
+        <p:txBody>
+          <a:bodyPr wrap="square">
+            <a:spAutoFit/>
+          </a:bodyPr>
+          <a:lstStyle/>
+          <a:p>
+            <a:r>
+              <a:rPr sz="1200" b="0" i="0">
+                <a:solidFill>
+                  <a:srgbClr val="C97B2C"/>
+                </a:solidFill>
+              </a:rPr>
+              <a:t>• </a:t>
+            </a:r>
+            <a:r>
+              <a:rPr sz="1200" b="1" i="0">
+                <a:solidFill>
+                  <a:srgbClr val="1D1D1D"/>
+                </a:solidFill>
+              </a:rPr>
+              <a:t>qwen3.5:35b: </a:t>
+            </a:r>
+            <a:r>
+              <a:rPr sz="1200" b="0" i="0">
+                <a:solidFill>
+                  <a:srgbClr val="1D1D1D"/>
+                </a:solidFill>
+              </a:rPr>
+              <a:t>multimodal generator, Q4-quantized MoE, fits on one 48 GB GPU, 262k context</a:t>
+            </a:r>
+          </a:p>
+        </p:txBody>
+      </p:sp>
+      <p:sp>
+        <p:nvSpPr>
+          <p:cNvPr id="61" name="TextBox 60"/>
+          <p:cNvSpPr txBox="1"/>
+          <p:nvPr/>
+        </p:nvSpPr>
+        <p:spPr>
+          <a:xfrm>
+            <a:off x="11295000" y="15462222"/>
+            <a:ext cx="9855000" cy="491040"/>
+          </a:xfrm>
+          <a:prstGeom prst="rect">
+            <a:avLst/>
+          </a:prstGeom>
+          <a:noFill/>
+        </p:spPr>
+        <p:txBody>
+          <a:bodyPr wrap="square">
+            <a:spAutoFit/>
+          </a:bodyPr>
+          <a:lstStyle/>
+          <a:p>
+            <a:r>
+              <a:rPr sz="1200" b="0" i="0">
+                <a:solidFill>
+                  <a:srgbClr val="C97B2C"/>
+                </a:solidFill>
+              </a:rPr>
+              <a:t>• </a:t>
+            </a:r>
+            <a:r>
+              <a:rPr sz="1200" b="1" i="0">
+                <a:solidFill>
+                  <a:srgbClr val="1D1D1D"/>
+                </a:solidFill>
+              </a:rPr>
+              <a:t>llama3.1:8b: </a:t>
+            </a:r>
+            <a:r>
+              <a:rPr sz="1200" b="0" i="0">
+                <a:solidFill>
+                  <a:srgbClr val="1D1D1D"/>
+                </a:solidFill>
+              </a:rPr>
+              <a:t>judge from a different model family (Meta vs Alibaba) to reduce self-preference bias</a:t>
+            </a:r>
+          </a:p>
+        </p:txBody>
+      </p:sp>
+      <p:sp>
+        <p:nvSpPr>
+          <p:cNvPr id="62" name="TextBox 61"/>
+          <p:cNvSpPr txBox="1"/>
+          <p:nvPr/>
+        </p:nvSpPr>
+        <p:spPr>
+          <a:xfrm>
+            <a:off x="11223000" y="15953262"/>
+            <a:ext cx="9927000" cy="432000"/>
+          </a:xfrm>
+          <a:prstGeom prst="rect">
+            <a:avLst/>
+          </a:prstGeom>
+          <a:noFill/>
+        </p:spPr>
+        <p:txBody>
+          <a:bodyPr wrap="square">
+            <a:spAutoFit/>
+          </a:bodyPr>
+          <a:lstStyle/>
+          <a:p>
+            <a:r>
+              <a:rPr sz="1100" b="0" i="0">
+                <a:solidFill>
+                  <a:srgbClr val="666666"/>
+                </a:solidFill>
+              </a:rPr>
+              <a:t>All components are open-weights and run on a single GPU.</a:t>
+            </a:r>
+          </a:p>
+        </p:txBody>
+      </p:sp>
+      <p:sp>
+        <p:nvSpPr>
+          <p:cNvPr id="63" name="Rectangle 62"/>
+          <p:cNvSpPr/>
+          <p:nvPr/>
+        </p:nvSpPr>
+        <p:spPr>
+          <a:xfrm>
+            <a:off x="11223000" y="16511262"/>
+            <a:ext cx="72000" cy="324000"/>
+          </a:xfrm>
+          <a:prstGeom prst="rect">
+            <a:avLst/>
+          </a:prstGeom>
+          <a:solidFill>
+            <a:srgbClr val="C97B2C"/>
+          </a:solidFill>
+          <a:ln/>
+        </p:spPr>
+        <p:style>
+          <a:lnRef idx="1">
+            <a:schemeClr val="accent1"/>
+          </a:lnRef>
+          <a:fillRef idx="3">
+            <a:schemeClr val="accent1"/>
+          </a:fillRef>
+          <a:effectRef idx="2">
+            <a:schemeClr val="accent1"/>
+          </a:effectRef>
+          <a:fontRef idx="minor">
+            <a:schemeClr val="lt1"/>
+          </a:fontRef>
+        </p:style>
+        <p:txBody>
+          <a:bodyPr rtlCol="0" anchor="ctr"/>
+          <a:lstStyle/>
+          <a:p>
+            <a:pPr algn="ctr"/>
+          </a:p>
+        </p:txBody>
+      </p:sp>
+      <p:sp>
+        <p:nvSpPr>
+          <p:cNvPr id="64" name="TextBox 63"/>
+          <p:cNvSpPr txBox="1"/>
+          <p:nvPr/>
+        </p:nvSpPr>
+        <p:spPr>
+          <a:xfrm>
+            <a:off x="11403000" y="16457262"/>
+            <a:ext cx="9747000" cy="432000"/>
+          </a:xfrm>
+          <a:prstGeom prst="rect">
+            <a:avLst/>
+          </a:prstGeom>
+          <a:noFill/>
+        </p:spPr>
+        <p:txBody>
+          <a:bodyPr wrap="square">
+            <a:spAutoFit/>
+          </a:bodyPr>
+          <a:lstStyle/>
+          <a:p>
+            <a:r>
+              <a:rPr sz="1500" b="1" i="0">
+                <a:solidFill>
+                  <a:srgbClr val="1B3A6B"/>
+                </a:solidFill>
+              </a:rPr>
+              <a:t>DeepSeek-OCR-2</a:t>
+            </a:r>
+          </a:p>
+        </p:txBody>
+      </p:sp>
+      <p:sp>
+        <p:nvSpPr>
+          <p:cNvPr id="65" name="TextBox 64"/>
+          <p:cNvSpPr txBox="1"/>
+          <p:nvPr/>
+        </p:nvSpPr>
+        <p:spPr>
+          <a:xfrm>
+            <a:off x="11223000" y="16925262"/>
+            <a:ext cx="9927000" cy="936000"/>
+          </a:xfrm>
+          <a:prstGeom prst="rect">
+            <a:avLst/>
+          </a:prstGeom>
+          <a:noFill/>
+        </p:spPr>
+        <p:txBody>
+          <a:bodyPr wrap="square">
+            <a:spAutoFit/>
+          </a:bodyPr>
+          <a:lstStyle/>
+          <a:p>
+            <a:r>
               <a:rPr sz="1300" b="0" i="0">
                 <a:solidFill>
                   <a:srgbClr val="1D1D1D"/>
@@ -5011,7 +5830,7 @@
       </p:sp>
       <p:pic>
         <p:nvPicPr>
-          <p:cNvPr id="49" name="Picture 48" descr="deepseek_ocr2_fig3.jpg"/>
+          <p:cNvPr id="66" name="Picture 65" descr="deepseek_ocr2_fig3.jpg"/>
           <p:cNvPicPr>
             <a:picLocks noChangeAspect="1"/>
           </p:cNvPicPr>
@@ -5025,7 +5844,7 @@
         </p:blipFill>
         <p:spPr>
           <a:xfrm>
-            <a:off x="11223000" y="11082240"/>
+            <a:off x="11223000" y="17933262"/>
             <a:ext cx="9927000" cy="3209730"/>
           </a:xfrm>
           <a:prstGeom prst="rect">
@@ -5035,13 +5854,13 @@
       </p:pic>
       <p:sp>
         <p:nvSpPr>
-          <p:cNvPr id="50" name="Rectangle 49"/>
+          <p:cNvPr id="67" name="Rectangle 66"/>
           <p:cNvSpPr/>
           <p:nvPr/>
         </p:nvSpPr>
         <p:spPr>
           <a:xfrm>
-            <a:off x="11223000" y="14525970"/>
+            <a:off x="11223000" y="21376992"/>
             <a:ext cx="72000" cy="324000"/>
           </a:xfrm>
           <a:prstGeom prst="rect">
@@ -5076,13 +5895,13 @@
       </p:sp>
       <p:sp>
         <p:nvSpPr>
-          <p:cNvPr id="51" name="TextBox 50"/>
+          <p:cNvPr id="68" name="TextBox 67"/>
           <p:cNvSpPr txBox="1"/>
           <p:nvPr/>
         </p:nvSpPr>
         <p:spPr>
           <a:xfrm>
-            <a:off x="11403000" y="14471970"/>
+            <a:off x="11403000" y="21322992"/>
             <a:ext cx="9747000" cy="432000"/>
           </a:xfrm>
           <a:prstGeom prst="rect">
@@ -5109,13 +5928,13 @@
       </p:sp>
       <p:sp>
         <p:nvSpPr>
-          <p:cNvPr id="52" name="TextBox 51"/>
+          <p:cNvPr id="69" name="TextBox 68"/>
           <p:cNvSpPr txBox="1"/>
           <p:nvPr/>
         </p:nvSpPr>
         <p:spPr>
           <a:xfrm>
-            <a:off x="11295000" y="14939970"/>
+            <a:off x="11295000" y="21790992"/>
             <a:ext cx="9855000" cy="491040"/>
           </a:xfrm>
           <a:prstGeom prst="rect">
@@ -5158,13 +5977,13 @@
       </p:sp>
       <p:sp>
         <p:nvSpPr>
-          <p:cNvPr id="53" name="TextBox 52"/>
+          <p:cNvPr id="70" name="TextBox 69"/>
           <p:cNvSpPr txBox="1"/>
           <p:nvPr/>
         </p:nvSpPr>
         <p:spPr>
           <a:xfrm>
-            <a:off x="11295000" y="15359010"/>
+            <a:off x="11295000" y="22210032"/>
             <a:ext cx="9855000" cy="491040"/>
           </a:xfrm>
           <a:prstGeom prst="rect">
@@ -5207,13 +6026,13 @@
       </p:sp>
       <p:sp>
         <p:nvSpPr>
-          <p:cNvPr id="54" name="TextBox 53"/>
+          <p:cNvPr id="71" name="TextBox 70"/>
           <p:cNvSpPr txBox="1"/>
           <p:nvPr/>
         </p:nvSpPr>
         <p:spPr>
           <a:xfrm>
-            <a:off x="11295000" y="15778050"/>
+            <a:off x="11295000" y="22629072"/>
             <a:ext cx="9855000" cy="491040"/>
           </a:xfrm>
           <a:prstGeom prst="rect">
@@ -5256,13 +6075,13 @@
       </p:sp>
       <p:sp>
         <p:nvSpPr>
-          <p:cNvPr id="55" name="TextBox 54"/>
+          <p:cNvPr id="72" name="TextBox 71"/>
           <p:cNvSpPr txBox="1"/>
           <p:nvPr/>
         </p:nvSpPr>
         <p:spPr>
           <a:xfrm>
-            <a:off x="11295000" y="16197090"/>
+            <a:off x="11295000" y="23048112"/>
             <a:ext cx="9855000" cy="491040"/>
           </a:xfrm>
           <a:prstGeom prst="rect">
@@ -5305,7 +6124,7 @@
       </p:sp>
       <p:sp>
         <p:nvSpPr>
-          <p:cNvPr id="56" name="Rectangle 55"/>
+          <p:cNvPr id="73" name="Rectangle 72"/>
           <p:cNvSpPr/>
           <p:nvPr/>
         </p:nvSpPr>
@@ -5346,7 +6165,7 @@
       </p:sp>
       <p:sp>
         <p:nvSpPr>
-          <p:cNvPr id="57" name="TextBox 56"/>
+          <p:cNvPr id="74" name="TextBox 73"/>
           <p:cNvSpPr txBox="1"/>
           <p:nvPr/>
         </p:nvSpPr>
@@ -5379,7 +6198,7 @@
       </p:sp>
       <p:sp>
         <p:nvSpPr>
-          <p:cNvPr id="58" name="Rectangle 57"/>
+          <p:cNvPr id="75" name="Rectangle 74"/>
           <p:cNvSpPr/>
           <p:nvPr/>
         </p:nvSpPr>
@@ -5420,7 +6239,7 @@
       </p:sp>
       <p:sp>
         <p:nvSpPr>
-          <p:cNvPr id="59" name="TextBox 58"/>
+          <p:cNvPr id="76" name="TextBox 75"/>
           <p:cNvSpPr txBox="1"/>
           <p:nvPr/>
         </p:nvSpPr>
@@ -5453,7 +6272,7 @@
       </p:sp>
       <p:graphicFrame>
         <p:nvGraphicFramePr>
-          <p:cNvPr id="60" name="Table 59"/>
+          <p:cNvPr id="77" name="Table 76"/>
           <p:cNvGraphicFramePr>
             <a:graphicFrameLocks noGrp="1"/>
           </p:cNvGraphicFramePr>
@@ -5873,7 +6692,7 @@
       </p:graphicFrame>
       <p:sp>
         <p:nvSpPr>
-          <p:cNvPr id="61" name="Rectangle 60"/>
+          <p:cNvPr id="78" name="Rectangle 77"/>
           <p:cNvSpPr/>
           <p:nvPr/>
         </p:nvSpPr>
@@ -5914,7 +6733,7 @@
       </p:sp>
       <p:sp>
         <p:nvSpPr>
-          <p:cNvPr id="62" name="TextBox 61"/>
+          <p:cNvPr id="79" name="TextBox 78"/>
           <p:cNvSpPr txBox="1"/>
           <p:nvPr/>
         </p:nvSpPr>
@@ -5947,7 +6766,7 @@
       </p:sp>
       <p:graphicFrame>
         <p:nvGraphicFramePr>
-          <p:cNvPr id="63" name="Table 62"/>
+          <p:cNvPr id="80" name="Table 79"/>
           <p:cNvGraphicFramePr>
             <a:graphicFrameLocks noGrp="1"/>
           </p:cNvGraphicFramePr>
@@ -6611,7 +7430,7 @@
       </p:graphicFrame>
       <p:sp>
         <p:nvSpPr>
-          <p:cNvPr id="64" name="Rectangle 63"/>
+          <p:cNvPr id="81" name="Rectangle 80"/>
           <p:cNvSpPr/>
           <p:nvPr/>
         </p:nvSpPr>
@@ -6652,7 +7471,7 @@
       </p:sp>
       <p:sp>
         <p:nvSpPr>
-          <p:cNvPr id="65" name="TextBox 64"/>
+          <p:cNvPr id="82" name="TextBox 81"/>
           <p:cNvSpPr txBox="1"/>
           <p:nvPr/>
         </p:nvSpPr>
@@ -6685,7 +7504,7 @@
       </p:sp>
       <p:graphicFrame>
         <p:nvGraphicFramePr>
-          <p:cNvPr id="66" name="Table 65"/>
+          <p:cNvPr id="83" name="Table 82"/>
           <p:cNvGraphicFramePr>
             <a:graphicFrameLocks noGrp="1"/>
           </p:cNvGraphicFramePr>
@@ -7434,7 +8253,7 @@
       </p:graphicFrame>
       <p:sp>
         <p:nvSpPr>
-          <p:cNvPr id="67" name="Rectangle 66"/>
+          <p:cNvPr id="84" name="Rectangle 83"/>
           <p:cNvSpPr/>
           <p:nvPr/>
         </p:nvSpPr>
@@ -7475,7 +8294,7 @@
       </p:sp>
       <p:sp>
         <p:nvSpPr>
-          <p:cNvPr id="68" name="TextBox 67"/>
+          <p:cNvPr id="85" name="TextBox 84"/>
           <p:cNvSpPr txBox="1"/>
           <p:nvPr/>
         </p:nvSpPr>
@@ -7508,7 +8327,7 @@
       </p:sp>
       <p:sp>
         <p:nvSpPr>
-          <p:cNvPr id="69" name="Rectangle 68"/>
+          <p:cNvPr id="86" name="Rectangle 85"/>
           <p:cNvSpPr/>
           <p:nvPr/>
         </p:nvSpPr>
@@ -7549,7 +8368,7 @@
       </p:sp>
       <p:sp>
         <p:nvSpPr>
-          <p:cNvPr id="70" name="Rectangle 69"/>
+          <p:cNvPr id="87" name="Rectangle 86"/>
           <p:cNvSpPr/>
           <p:nvPr/>
         </p:nvSpPr>
@@ -7590,7 +8409,7 @@
       </p:sp>
       <p:sp>
         <p:nvSpPr>
-          <p:cNvPr id="71" name="TextBox 70"/>
+          <p:cNvPr id="88" name="TextBox 87"/>
           <p:cNvSpPr txBox="1"/>
           <p:nvPr/>
         </p:nvSpPr>
@@ -7623,7 +8442,7 @@
       </p:sp>
       <p:sp>
         <p:nvSpPr>
-          <p:cNvPr id="72" name="TextBox 71"/>
+          <p:cNvPr id="89" name="TextBox 88"/>
           <p:cNvSpPr txBox="1"/>
           <p:nvPr/>
         </p:nvSpPr>
@@ -7672,7 +8491,7 @@
       </p:sp>
       <p:sp>
         <p:nvSpPr>
-          <p:cNvPr id="73" name="TextBox 72"/>
+          <p:cNvPr id="90" name="TextBox 89"/>
           <p:cNvSpPr txBox="1"/>
           <p:nvPr/>
         </p:nvSpPr>
@@ -7721,7 +8540,7 @@
       </p:sp>
       <p:sp>
         <p:nvSpPr>
-          <p:cNvPr id="74" name="TextBox 73"/>
+          <p:cNvPr id="91" name="TextBox 90"/>
           <p:cNvSpPr txBox="1"/>
           <p:nvPr/>
         </p:nvSpPr>
@@ -7770,7 +8589,7 @@
       </p:sp>
       <p:sp>
         <p:nvSpPr>
-          <p:cNvPr id="75" name="TextBox 74"/>
+          <p:cNvPr id="92" name="TextBox 91"/>
           <p:cNvSpPr txBox="1"/>
           <p:nvPr/>
         </p:nvSpPr>
@@ -7819,7 +8638,7 @@
       </p:sp>
       <p:sp>
         <p:nvSpPr>
-          <p:cNvPr id="76" name="TextBox 75"/>
+          <p:cNvPr id="93" name="TextBox 92"/>
           <p:cNvSpPr txBox="1"/>
           <p:nvPr/>
         </p:nvSpPr>
@@ -7868,7 +8687,7 @@
       </p:sp>
       <p:sp>
         <p:nvSpPr>
-          <p:cNvPr id="77" name="TextBox 76"/>
+          <p:cNvPr id="94" name="TextBox 93"/>
           <p:cNvSpPr txBox="1"/>
           <p:nvPr/>
         </p:nvSpPr>
@@ -7917,7 +8736,7 @@
       </p:sp>
       <p:sp>
         <p:nvSpPr>
-          <p:cNvPr id="78" name="Rectangle 77"/>
+          <p:cNvPr id="95" name="Rectangle 94"/>
           <p:cNvSpPr/>
           <p:nvPr/>
         </p:nvSpPr>
@@ -7958,7 +8777,7 @@
       </p:sp>
       <p:sp>
         <p:nvSpPr>
-          <p:cNvPr id="79" name="TextBox 78"/>
+          <p:cNvPr id="96" name="TextBox 95"/>
           <p:cNvSpPr txBox="1"/>
           <p:nvPr/>
         </p:nvSpPr>
@@ -7991,7 +8810,7 @@
       </p:sp>
       <p:sp>
         <p:nvSpPr>
-          <p:cNvPr id="80" name="Rectangle 79"/>
+          <p:cNvPr id="97" name="Rectangle 96"/>
           <p:cNvSpPr/>
           <p:nvPr/>
         </p:nvSpPr>
@@ -8032,7 +8851,7 @@
       </p:sp>
       <p:sp>
         <p:nvSpPr>
-          <p:cNvPr id="81" name="TextBox 80"/>
+          <p:cNvPr id="98" name="TextBox 97"/>
           <p:cNvSpPr txBox="1"/>
           <p:nvPr/>
         </p:nvSpPr>
@@ -8065,7 +8884,7 @@
       </p:sp>
       <p:sp>
         <p:nvSpPr>
-          <p:cNvPr id="82" name="TextBox 81"/>
+          <p:cNvPr id="99" name="TextBox 98"/>
           <p:cNvSpPr txBox="1"/>
           <p:nvPr/>
         </p:nvSpPr>
@@ -8114,7 +8933,7 @@
       </p:sp>
       <p:sp>
         <p:nvSpPr>
-          <p:cNvPr id="83" name="TextBox 82"/>
+          <p:cNvPr id="100" name="TextBox 99"/>
           <p:cNvSpPr txBox="1"/>
           <p:nvPr/>
         </p:nvSpPr>
@@ -8163,7 +8982,7 @@
       </p:sp>
       <p:sp>
         <p:nvSpPr>
-          <p:cNvPr id="84" name="Rectangle 83"/>
+          <p:cNvPr id="101" name="Rectangle 100"/>
           <p:cNvSpPr/>
           <p:nvPr/>
         </p:nvSpPr>
@@ -8204,7 +9023,7 @@
       </p:sp>
       <p:sp>
         <p:nvSpPr>
-          <p:cNvPr id="85" name="TextBox 84"/>
+          <p:cNvPr id="102" name="TextBox 101"/>
           <p:cNvSpPr txBox="1"/>
           <p:nvPr/>
         </p:nvSpPr>
@@ -8237,7 +9056,7 @@
       </p:sp>
       <p:sp>
         <p:nvSpPr>
-          <p:cNvPr id="86" name="TextBox 85"/>
+          <p:cNvPr id="103" name="TextBox 102"/>
           <p:cNvSpPr txBox="1"/>
           <p:nvPr/>
         </p:nvSpPr>
@@ -8286,7 +9105,7 @@
       </p:sp>
       <p:sp>
         <p:nvSpPr>
-          <p:cNvPr id="87" name="TextBox 86"/>
+          <p:cNvPr id="104" name="TextBox 103"/>
           <p:cNvSpPr txBox="1"/>
           <p:nvPr/>
         </p:nvSpPr>
@@ -8335,7 +9154,7 @@
       </p:sp>
       <p:sp>
         <p:nvSpPr>
-          <p:cNvPr id="88" name="TextBox 87"/>
+          <p:cNvPr id="105" name="TextBox 104"/>
           <p:cNvSpPr txBox="1"/>
           <p:nvPr/>
         </p:nvSpPr>
@@ -8384,7 +9203,7 @@
       </p:sp>
       <p:sp>
         <p:nvSpPr>
-          <p:cNvPr id="89" name="TextBox 88"/>
+          <p:cNvPr id="106" name="TextBox 105"/>
           <p:cNvSpPr txBox="1"/>
           <p:nvPr/>
         </p:nvSpPr>
@@ -8433,7 +9252,7 @@
       </p:sp>
       <p:sp>
         <p:nvSpPr>
-          <p:cNvPr id="90" name="Rectangle 89"/>
+          <p:cNvPr id="107" name="Rectangle 106"/>
           <p:cNvSpPr/>
           <p:nvPr/>
         </p:nvSpPr>
@@ -8474,7 +9293,7 @@
       </p:sp>
       <p:sp>
         <p:nvSpPr>
-          <p:cNvPr id="91" name="TextBox 90"/>
+          <p:cNvPr id="108" name="TextBox 107"/>
           <p:cNvSpPr txBox="1"/>
           <p:nvPr/>
         </p:nvSpPr>
@@ -8507,7 +9326,7 @@
       </p:sp>
       <p:sp>
         <p:nvSpPr>
-          <p:cNvPr id="92" name="TextBox 91"/>
+          <p:cNvPr id="109" name="TextBox 108"/>
           <p:cNvSpPr txBox="1"/>
           <p:nvPr/>
         </p:nvSpPr>
@@ -8556,7 +9375,7 @@
       </p:sp>
       <p:sp>
         <p:nvSpPr>
-          <p:cNvPr id="93" name="TextBox 92"/>
+          <p:cNvPr id="110" name="TextBox 109"/>
           <p:cNvSpPr txBox="1"/>
           <p:nvPr/>
         </p:nvSpPr>
@@ -8605,7 +9424,7 @@
       </p:sp>
       <p:sp>
         <p:nvSpPr>
-          <p:cNvPr id="94" name="TextBox 93"/>
+          <p:cNvPr id="111" name="TextBox 110"/>
           <p:cNvSpPr txBox="1"/>
           <p:nvPr/>
         </p:nvSpPr>
@@ -8654,7 +9473,7 @@
       </p:sp>
       <p:sp>
         <p:nvSpPr>
-          <p:cNvPr id="95" name="TextBox 94"/>
+          <p:cNvPr id="112" name="TextBox 111"/>
           <p:cNvSpPr txBox="1"/>
           <p:nvPr/>
         </p:nvSpPr>
@@ -8703,7 +9522,7 @@
       </p:sp>
       <p:sp>
         <p:nvSpPr>
-          <p:cNvPr id="96" name="Rectangle 95"/>
+          <p:cNvPr id="113" name="Rectangle 112"/>
           <p:cNvSpPr/>
           <p:nvPr/>
         </p:nvSpPr>
@@ -8744,7 +9563,7 @@
       </p:sp>
       <p:sp>
         <p:nvSpPr>
-          <p:cNvPr id="97" name="TextBox 96"/>
+          <p:cNvPr id="114" name="TextBox 113"/>
           <p:cNvSpPr txBox="1"/>
           <p:nvPr/>
         </p:nvSpPr>

</xml_diff>